<commit_message>
feat: add presenter notes to all 16 slides; fix layout overflows on S8/S11/S13/S14/S15
- Added add_notes() helper (notes_text_frame API) and speaker notes on all 16 slides
- Fixed 5 slides where shapes extended beyond the 7.5-inch slide boundary:
  S8  RAG: before/after boxes h 2.72→1.82 (was ending at y=7.96)
  S11 RLHF: RM Dashboard h 3.65→2.20; item spacing 0.80→0.46 (was y=8.62)
  S13 Prompts: variant card h 4.60→3.92; Q3 boxes repositioned (was y=8.26)
  S14 Eval: suite rows spacing 0.78→0.62; latency rows 0.58→0.40; root-cause moved to footnote
  S15 ROI: qualitative strip row spacing 0.72→0.50 (was y=7.80)
- Zero overflows detected across all 16 slides post-fix
- Slide content unchanged; only coordinates and presenter notes added

Co-Authored-By: Claude Sonnet 4.6 <noreply@anthropic.com>
</commit_message>
<xml_diff>
--- a/docs/capstone_presentation.pptx
+++ b/docs/capstone_presentation.pptx
@@ -6,21 +6,21 @@
   </p:sldMasterIdLst>
   <p:sldIdLst>
     <p:sldId id="256" r:id="rId7"/>
-    <p:sldId id="257" r:id="rId8"/>
-    <p:sldId id="258" r:id="rId9"/>
-    <p:sldId id="259" r:id="rId10"/>
-    <p:sldId id="260" r:id="rId11"/>
-    <p:sldId id="261" r:id="rId12"/>
-    <p:sldId id="262" r:id="rId13"/>
-    <p:sldId id="263" r:id="rId14"/>
-    <p:sldId id="264" r:id="rId15"/>
-    <p:sldId id="265" r:id="rId16"/>
-    <p:sldId id="266" r:id="rId17"/>
-    <p:sldId id="267" r:id="rId18"/>
-    <p:sldId id="268" r:id="rId19"/>
-    <p:sldId id="269" r:id="rId20"/>
-    <p:sldId id="270" r:id="rId21"/>
-    <p:sldId id="271" r:id="rId22"/>
+    <p:sldId id="257" r:id="rId9"/>
+    <p:sldId id="258" r:id="rId10"/>
+    <p:sldId id="259" r:id="rId11"/>
+    <p:sldId id="260" r:id="rId12"/>
+    <p:sldId id="261" r:id="rId13"/>
+    <p:sldId id="262" r:id="rId14"/>
+    <p:sldId id="263" r:id="rId15"/>
+    <p:sldId id="264" r:id="rId16"/>
+    <p:sldId id="265" r:id="rId17"/>
+    <p:sldId id="266" r:id="rId18"/>
+    <p:sldId id="267" r:id="rId19"/>
+    <p:sldId id="268" r:id="rId20"/>
+    <p:sldId id="269" r:id="rId21"/>
+    <p:sldId id="270" r:id="rId22"/>
+    <p:sldId id="271" r:id="rId23"/>
   </p:sldIdLst>
   <p:sldSz cx="12188952" cy="6858000" type="screen4x3"/>
   <p:notesSz cx="6858000" cy="9144000"/>
@@ -120,6 +120,1801 @@
     </a:lvl9pPr>
   </p:defaultTextStyle>
 </p:presentation>
+</file>
+
+<file path=ppt/notesMasters/notesMaster1.xml><?xml version="1.0" encoding="utf-8"?>
+<p:notesMaster xmlns:a="http://schemas.openxmlformats.org/drawingml/2006/main" xmlns:p="http://schemas.openxmlformats.org/presentationml/2006/main" xmlns:r="http://schemas.openxmlformats.org/officeDocument/2006/relationships">
+  <p:cSld>
+    <p:bg>
+      <p:bgRef idx="1001">
+        <a:schemeClr val="bg1"/>
+      </p:bgRef>
+    </p:bg>
+    <p:spTree>
+      <p:nvGrpSpPr>
+        <p:cNvPr id="1" name=""/>
+        <p:cNvGrpSpPr/>
+        <p:nvPr/>
+      </p:nvGrpSpPr>
+      <p:grpSpPr>
+        <a:xfrm>
+          <a:off x="0" y="0"/>
+          <a:ext cx="0" cy="0"/>
+          <a:chOff x="0" y="0"/>
+          <a:chExt cx="0" cy="0"/>
+        </a:xfrm>
+      </p:grpSpPr>
+      <p:sp>
+        <p:nvSpPr>
+          <p:cNvPr id="2" name="Header Placeholder 1"/>
+          <p:cNvSpPr>
+            <a:spLocks noGrp="1"/>
+          </p:cNvSpPr>
+          <p:nvPr>
+            <p:ph type="hdr" sz="quarter"/>
+          </p:nvPr>
+        </p:nvSpPr>
+        <p:spPr>
+          <a:xfrm>
+            <a:off x="0" y="0"/>
+            <a:ext cx="2971800" cy="457200"/>
+          </a:xfrm>
+          <a:prstGeom prst="rect">
+            <a:avLst/>
+          </a:prstGeom>
+        </p:spPr>
+        <p:txBody>
+          <a:bodyPr vert="horz" lIns="91440" tIns="45720" rIns="91440" bIns="45720" rtlCol="0"/>
+          <a:lstStyle>
+            <a:lvl1pPr algn="l">
+              <a:defRPr sz="1200"/>
+            </a:lvl1pPr>
+          </a:lstStyle>
+          <a:p>
+            <a:endParaRPr lang="en-US"/>
+          </a:p>
+        </p:txBody>
+      </p:sp>
+      <p:sp>
+        <p:nvSpPr>
+          <p:cNvPr id="3" name="Date Placeholder 2"/>
+          <p:cNvSpPr>
+            <a:spLocks noGrp="1"/>
+          </p:cNvSpPr>
+          <p:nvPr>
+            <p:ph type="dt" idx="1"/>
+          </p:nvPr>
+        </p:nvSpPr>
+        <p:spPr>
+          <a:xfrm>
+            <a:off x="3884613" y="0"/>
+            <a:ext cx="2971800" cy="457200"/>
+          </a:xfrm>
+          <a:prstGeom prst="rect">
+            <a:avLst/>
+          </a:prstGeom>
+        </p:spPr>
+        <p:txBody>
+          <a:bodyPr vert="horz" lIns="91440" tIns="45720" rIns="91440" bIns="45720" rtlCol="0"/>
+          <a:lstStyle>
+            <a:lvl1pPr algn="r">
+              <a:defRPr sz="1200"/>
+            </a:lvl1pPr>
+          </a:lstStyle>
+          <a:p>
+            <a:fld id="{0F89C1C7-3DCD-1040-A9CF-14679D8B5DDD}" type="datetimeFigureOut">
+              <a:rPr lang="en-US" smtClean="0"/>
+              <a:t>10/17/16</a:t>
+            </a:fld>
+            <a:endParaRPr lang="en-US"/>
+          </a:p>
+        </p:txBody>
+      </p:sp>
+      <p:sp>
+        <p:nvSpPr>
+          <p:cNvPr id="4" name="Slide Image Placeholder 3"/>
+          <p:cNvSpPr>
+            <a:spLocks noGrp="1" noRot="1" noChangeAspect="1"/>
+          </p:cNvSpPr>
+          <p:nvPr>
+            <p:ph type="sldImg" idx="2"/>
+          </p:nvPr>
+        </p:nvSpPr>
+        <p:spPr>
+          <a:xfrm>
+            <a:off x="1143000" y="685800"/>
+            <a:ext cx="4572000" cy="3429000"/>
+          </a:xfrm>
+          <a:prstGeom prst="rect">
+            <a:avLst/>
+          </a:prstGeom>
+          <a:noFill/>
+          <a:ln w="12700">
+            <a:solidFill>
+              <a:prstClr val="black"/>
+            </a:solidFill>
+          </a:ln>
+        </p:spPr>
+        <p:txBody>
+          <a:bodyPr vert="horz" lIns="91440" tIns="45720" rIns="91440" bIns="45720" rtlCol="0" anchor="ctr"/>
+          <a:lstStyle/>
+          <a:p>
+            <a:endParaRPr lang="en-US"/>
+          </a:p>
+        </p:txBody>
+      </p:sp>
+      <p:sp>
+        <p:nvSpPr>
+          <p:cNvPr id="5" name="Notes Placeholder 4"/>
+          <p:cNvSpPr>
+            <a:spLocks noGrp="1"/>
+          </p:cNvSpPr>
+          <p:nvPr>
+            <p:ph type="body" sz="quarter" idx="3"/>
+          </p:nvPr>
+        </p:nvSpPr>
+        <p:spPr>
+          <a:xfrm>
+            <a:off x="685800" y="4343400"/>
+            <a:ext cx="5486400" cy="4114800"/>
+          </a:xfrm>
+          <a:prstGeom prst="rect">
+            <a:avLst/>
+          </a:prstGeom>
+        </p:spPr>
+        <p:txBody>
+          <a:bodyPr vert="horz" lIns="91440" tIns="45720" rIns="91440" bIns="45720" rtlCol="0"/>
+          <a:lstStyle/>
+          <a:p>
+            <a:pPr lvl="0"/>
+            <a:r>
+              <a:rPr lang="en-US" smtClean="0"/>
+              <a:t>Click to edit Master text styles</a:t>
+            </a:r>
+          </a:p>
+          <a:p>
+            <a:pPr lvl="1"/>
+            <a:r>
+              <a:rPr lang="en-US" smtClean="0"/>
+              <a:t>Second level</a:t>
+            </a:r>
+          </a:p>
+          <a:p>
+            <a:pPr lvl="2"/>
+            <a:r>
+              <a:rPr lang="en-US" smtClean="0"/>
+              <a:t>Third level</a:t>
+            </a:r>
+          </a:p>
+          <a:p>
+            <a:pPr lvl="3"/>
+            <a:r>
+              <a:rPr lang="en-US" smtClean="0"/>
+              <a:t>Fourth level</a:t>
+            </a:r>
+          </a:p>
+          <a:p>
+            <a:pPr lvl="4"/>
+            <a:r>
+              <a:rPr lang="en-US" smtClean="0"/>
+              <a:t>Fifth level</a:t>
+            </a:r>
+            <a:endParaRPr lang="en-US"/>
+          </a:p>
+        </p:txBody>
+      </p:sp>
+      <p:sp>
+        <p:nvSpPr>
+          <p:cNvPr id="6" name="Footer Placeholder 5"/>
+          <p:cNvSpPr>
+            <a:spLocks noGrp="1"/>
+          </p:cNvSpPr>
+          <p:nvPr>
+            <p:ph type="ftr" sz="quarter" idx="4"/>
+          </p:nvPr>
+        </p:nvSpPr>
+        <p:spPr>
+          <a:xfrm>
+            <a:off x="0" y="8685213"/>
+            <a:ext cx="2971800" cy="457200"/>
+          </a:xfrm>
+          <a:prstGeom prst="rect">
+            <a:avLst/>
+          </a:prstGeom>
+        </p:spPr>
+        <p:txBody>
+          <a:bodyPr vert="horz" lIns="91440" tIns="45720" rIns="91440" bIns="45720" rtlCol="0" anchor="b"/>
+          <a:lstStyle>
+            <a:lvl1pPr algn="l">
+              <a:defRPr sz="1200"/>
+            </a:lvl1pPr>
+          </a:lstStyle>
+          <a:p>
+            <a:endParaRPr lang="en-US"/>
+          </a:p>
+        </p:txBody>
+      </p:sp>
+      <p:sp>
+        <p:nvSpPr>
+          <p:cNvPr id="7" name="Slide Number Placeholder 6"/>
+          <p:cNvSpPr>
+            <a:spLocks noGrp="1"/>
+          </p:cNvSpPr>
+          <p:nvPr>
+            <p:ph type="sldNum" sz="quarter" idx="5"/>
+          </p:nvPr>
+        </p:nvSpPr>
+        <p:spPr>
+          <a:xfrm>
+            <a:off x="3884613" y="8685213"/>
+            <a:ext cx="2971800" cy="457200"/>
+          </a:xfrm>
+          <a:prstGeom prst="rect">
+            <a:avLst/>
+          </a:prstGeom>
+        </p:spPr>
+        <p:txBody>
+          <a:bodyPr vert="horz" lIns="91440" tIns="45720" rIns="91440" bIns="45720" rtlCol="0" anchor="b"/>
+          <a:lstStyle>
+            <a:lvl1pPr algn="r">
+              <a:defRPr sz="1200"/>
+            </a:lvl1pPr>
+          </a:lstStyle>
+          <a:p>
+            <a:fld id="{BB5E49A5-4136-284D-997B-48E1D791AD67}" type="slidenum">
+              <a:rPr lang="en-US" smtClean="0"/>
+              <a:t>‹#›</a:t>
+            </a:fld>
+            <a:endParaRPr lang="en-US"/>
+          </a:p>
+        </p:txBody>
+      </p:sp>
+    </p:spTree>
+    <p:extLst>
+      <p:ext uri="{BB962C8B-B14F-4D97-AF65-F5344CB8AC3E}">
+        <p14:creationId xmlns:p14="http://schemas.microsoft.com/office/powerpoint/2010/main" val="2623252185"/>
+      </p:ext>
+    </p:extLst>
+  </p:cSld>
+  <p:clrMap bg1="lt1" tx1="dk1" bg2="lt2" tx2="dk2" accent1="accent1" accent2="accent2" accent3="accent3" accent4="accent4" accent5="accent5" accent6="accent6" hlink="hlink" folHlink="folHlink"/>
+  <p:notesStyle>
+    <a:lvl1pPr marL="0" algn="l" defTabSz="457200" rtl="0" eaLnBrk="1" latinLnBrk="0" hangingPunct="1">
+      <a:defRPr sz="1200" kern="1200">
+        <a:solidFill>
+          <a:schemeClr val="tx1"/>
+        </a:solidFill>
+        <a:latin typeface="+mn-lt"/>
+        <a:ea typeface="+mn-ea"/>
+        <a:cs typeface="+mn-cs"/>
+      </a:defRPr>
+    </a:lvl1pPr>
+    <a:lvl2pPr marL="457200" algn="l" defTabSz="457200" rtl="0" eaLnBrk="1" latinLnBrk="0" hangingPunct="1">
+      <a:defRPr sz="1200" kern="1200">
+        <a:solidFill>
+          <a:schemeClr val="tx1"/>
+        </a:solidFill>
+        <a:latin typeface="+mn-lt"/>
+        <a:ea typeface="+mn-ea"/>
+        <a:cs typeface="+mn-cs"/>
+      </a:defRPr>
+    </a:lvl2pPr>
+    <a:lvl3pPr marL="914400" algn="l" defTabSz="457200" rtl="0" eaLnBrk="1" latinLnBrk="0" hangingPunct="1">
+      <a:defRPr sz="1200" kern="1200">
+        <a:solidFill>
+          <a:schemeClr val="tx1"/>
+        </a:solidFill>
+        <a:latin typeface="+mn-lt"/>
+        <a:ea typeface="+mn-ea"/>
+        <a:cs typeface="+mn-cs"/>
+      </a:defRPr>
+    </a:lvl3pPr>
+    <a:lvl4pPr marL="1371600" algn="l" defTabSz="457200" rtl="0" eaLnBrk="1" latinLnBrk="0" hangingPunct="1">
+      <a:defRPr sz="1200" kern="1200">
+        <a:solidFill>
+          <a:schemeClr val="tx1"/>
+        </a:solidFill>
+        <a:latin typeface="+mn-lt"/>
+        <a:ea typeface="+mn-ea"/>
+        <a:cs typeface="+mn-cs"/>
+      </a:defRPr>
+    </a:lvl4pPr>
+    <a:lvl5pPr marL="1828800" algn="l" defTabSz="457200" rtl="0" eaLnBrk="1" latinLnBrk="0" hangingPunct="1">
+      <a:defRPr sz="1200" kern="1200">
+        <a:solidFill>
+          <a:schemeClr val="tx1"/>
+        </a:solidFill>
+        <a:latin typeface="+mn-lt"/>
+        <a:ea typeface="+mn-ea"/>
+        <a:cs typeface="+mn-cs"/>
+      </a:defRPr>
+    </a:lvl5pPr>
+    <a:lvl6pPr marL="2286000" algn="l" defTabSz="457200" rtl="0" eaLnBrk="1" latinLnBrk="0" hangingPunct="1">
+      <a:defRPr sz="1200" kern="1200">
+        <a:solidFill>
+          <a:schemeClr val="tx1"/>
+        </a:solidFill>
+        <a:latin typeface="+mn-lt"/>
+        <a:ea typeface="+mn-ea"/>
+        <a:cs typeface="+mn-cs"/>
+      </a:defRPr>
+    </a:lvl6pPr>
+    <a:lvl7pPr marL="2743200" algn="l" defTabSz="457200" rtl="0" eaLnBrk="1" latinLnBrk="0" hangingPunct="1">
+      <a:defRPr sz="1200" kern="1200">
+        <a:solidFill>
+          <a:schemeClr val="tx1"/>
+        </a:solidFill>
+        <a:latin typeface="+mn-lt"/>
+        <a:ea typeface="+mn-ea"/>
+        <a:cs typeface="+mn-cs"/>
+      </a:defRPr>
+    </a:lvl7pPr>
+    <a:lvl8pPr marL="3200400" algn="l" defTabSz="457200" rtl="0" eaLnBrk="1" latinLnBrk="0" hangingPunct="1">
+      <a:defRPr sz="1200" kern="1200">
+        <a:solidFill>
+          <a:schemeClr val="tx1"/>
+        </a:solidFill>
+        <a:latin typeface="+mn-lt"/>
+        <a:ea typeface="+mn-ea"/>
+        <a:cs typeface="+mn-cs"/>
+      </a:defRPr>
+    </a:lvl8pPr>
+    <a:lvl9pPr marL="3657600" algn="l" defTabSz="457200" rtl="0" eaLnBrk="1" latinLnBrk="0" hangingPunct="1">
+      <a:defRPr sz="1200" kern="1200">
+        <a:solidFill>
+          <a:schemeClr val="tx1"/>
+        </a:solidFill>
+        <a:latin typeface="+mn-lt"/>
+        <a:ea typeface="+mn-ea"/>
+        <a:cs typeface="+mn-cs"/>
+      </a:defRPr>
+    </a:lvl9pPr>
+  </p:notesStyle>
+</p:notesMaster>
+</file>
+
+<file path=ppt/notesSlides/notesSlide1.xml><?xml version="1.0" encoding="utf-8"?>
+<p:notes xmlns:a="http://schemas.openxmlformats.org/drawingml/2006/main" xmlns:p="http://schemas.openxmlformats.org/presentationml/2006/main" xmlns:r="http://schemas.openxmlformats.org/officeDocument/2006/relationships">
+  <p:cSld>
+    <p:spTree>
+      <p:nvGrpSpPr>
+        <p:cNvPr id="1" name=""/>
+        <p:cNvGrpSpPr/>
+        <p:nvPr/>
+      </p:nvGrpSpPr>
+      <p:grpSpPr>
+        <a:xfrm>
+          <a:off x="0" y="0"/>
+          <a:ext cx="0" cy="0"/>
+          <a:chOff x="0" y="0"/>
+          <a:chExt cx="0" cy="0"/>
+        </a:xfrm>
+      </p:grpSpPr>
+      <p:sp>
+        <p:nvSpPr>
+          <p:cNvPr id="2" name="Slide Image Placeholder 1"/>
+          <p:cNvSpPr>
+            <a:spLocks noGrp="1"/>
+          </p:cNvSpPr>
+          <p:nvPr>
+            <p:ph type="sldImg" idx="2"/>
+          </p:nvPr>
+        </p:nvSpPr>
+        <p:spPr/>
+      </p:sp>
+      <p:sp>
+        <p:nvSpPr>
+          <p:cNvPr id="3" name="Notes Placeholder 2"/>
+          <p:cNvSpPr>
+            <a:spLocks noGrp="1"/>
+          </p:cNvSpPr>
+          <p:nvPr>
+            <p:ph type="body" idx="3" sz="quarter"/>
+          </p:nvPr>
+        </p:nvSpPr>
+        <p:spPr/>
+        <p:txBody>
+          <a:bodyPr/>
+          <a:lstStyle/>
+          <a:p>
+            <a:r>
+              <a:t>Good [morning/afternoon] — this is my IIT Madras AI Capstone submission, Scenario 2 Banking, Track A LangChain.</a:t>
+            </a:r>
+          </a:p>
+          <a:p>
+            <a:r>
+              <a:t>The project is an AI Copilot that guides retail bank customers through early-stage loan origination.</a:t>
+            </a:r>
+          </a:p>
+          <a:p>
+            <a:r>
+              <a:t>It covers 4 loan products — Home, Personal, MSME, New Car — using 5 AI tools and a full RAG pipeline.</a:t>
+            </a:r>
+          </a:p>
+          <a:p>
+            <a:r>
+              <a:t>Built in 10 days across 8 phases; 233 tests passing. Let me walk you through the architecture and key decisions.</a:t>
+            </a:r>
+          </a:p>
+        </p:txBody>
+      </p:sp>
+      <p:sp>
+        <p:nvSpPr>
+          <p:cNvPr id="4" name="Slide Number Placeholder 3"/>
+          <p:cNvSpPr>
+            <a:spLocks noGrp="1"/>
+          </p:cNvSpPr>
+          <p:nvPr>
+            <p:ph type="sldNum" idx="5" sz="quarter"/>
+          </p:nvPr>
+        </p:nvSpPr>
+        <p:spPr/>
+      </p:sp>
+    </p:spTree>
+  </p:cSld>
+  <p:clrMapOvr>
+    <a:masterClrMapping/>
+  </p:clrMapOvr>
+</p:notes>
+</file>
+
+<file path=ppt/notesSlides/notesSlide10.xml><?xml version="1.0" encoding="utf-8"?>
+<p:notes xmlns:a="http://schemas.openxmlformats.org/drawingml/2006/main" xmlns:p="http://schemas.openxmlformats.org/presentationml/2006/main" xmlns:r="http://schemas.openxmlformats.org/officeDocument/2006/relationships">
+  <p:cSld>
+    <p:spTree>
+      <p:nvGrpSpPr>
+        <p:cNvPr id="1" name=""/>
+        <p:cNvGrpSpPr/>
+        <p:nvPr/>
+      </p:nvGrpSpPr>
+      <p:grpSpPr>
+        <a:xfrm>
+          <a:off x="0" y="0"/>
+          <a:ext cx="0" cy="0"/>
+          <a:chOff x="0" y="0"/>
+          <a:chExt cx="0" cy="0"/>
+        </a:xfrm>
+      </p:grpSpPr>
+      <p:sp>
+        <p:nvSpPr>
+          <p:cNvPr id="2" name="Slide Image Placeholder 1"/>
+          <p:cNvSpPr>
+            <a:spLocks noGrp="1"/>
+          </p:cNvSpPr>
+          <p:nvPr>
+            <p:ph type="sldImg" idx="2"/>
+          </p:nvPr>
+        </p:nvSpPr>
+        <p:spPr/>
+      </p:sp>
+      <p:sp>
+        <p:nvSpPr>
+          <p:cNvPr id="3" name="Notes Placeholder 2"/>
+          <p:cNvSpPr>
+            <a:spLocks noGrp="1"/>
+          </p:cNvSpPr>
+          <p:nvPr>
+            <p:ph type="body" idx="3" sz="quarter"/>
+          </p:nvPr>
+        </p:nvSpPr>
+        <p:spPr/>
+        <p:txBody>
+          <a:bodyPr/>
+          <a:lstStyle/>
+          <a:p>
+            <a:r>
+              <a:t>Memory has two complementary components: LangChain's sliding window (k=10) for prompt context, and CustomerProfile dataclass for structured state.</a:t>
+            </a:r>
+          </a:p>
+          <a:p>
+            <a:r>
+              <a:t>The Planner (next_question()) drives sequential profile collection — it never re-asks a field already in SessionState.</a:t>
+            </a:r>
+          </a:p>
+          <a:p>
+            <a:r>
+              <a:t>SessionState persists eligibility_result and emi_result so the agent can reference prior tool outputs without re-calling tools.</a:t>
+            </a:r>
+          </a:p>
+          <a:p>
+            <a:r>
+              <a:t>The 9-turn demo (right panel) shows a realistic MSME ceiling-breach scenario: Rajesh Mehta requests ₹5Cr → breach detected → mobile validation loop → escalation packet.</a:t>
+            </a:r>
+          </a:p>
+          <a:p>
+            <a:r>
+              <a:t>Reset flow: 'start over' clears both LangChain memory AND SessionState — same agent object, no re-init overhead.</a:t>
+            </a:r>
+          </a:p>
+        </p:txBody>
+      </p:sp>
+      <p:sp>
+        <p:nvSpPr>
+          <p:cNvPr id="4" name="Slide Number Placeholder 3"/>
+          <p:cNvSpPr>
+            <a:spLocks noGrp="1"/>
+          </p:cNvSpPr>
+          <p:nvPr>
+            <p:ph type="sldNum" idx="5" sz="quarter"/>
+          </p:nvPr>
+        </p:nvSpPr>
+        <p:spPr/>
+      </p:sp>
+    </p:spTree>
+  </p:cSld>
+  <p:clrMapOvr>
+    <a:masterClrMapping/>
+  </p:clrMapOvr>
+</p:notes>
+</file>
+
+<file path=ppt/notesSlides/notesSlide11.xml><?xml version="1.0" encoding="utf-8"?>
+<p:notes xmlns:a="http://schemas.openxmlformats.org/drawingml/2006/main" xmlns:p="http://schemas.openxmlformats.org/presentationml/2006/main" xmlns:r="http://schemas.openxmlformats.org/officeDocument/2006/relationships">
+  <p:cSld>
+    <p:spTree>
+      <p:nvGrpSpPr>
+        <p:cNvPr id="1" name=""/>
+        <p:cNvGrpSpPr/>
+        <p:nvPr/>
+      </p:nvGrpSpPr>
+      <p:grpSpPr>
+        <a:xfrm>
+          <a:off x="0" y="0"/>
+          <a:ext cx="0" cy="0"/>
+          <a:chOff x="0" y="0"/>
+          <a:chExt cx="0" cy="0"/>
+        </a:xfrm>
+      </p:grpSpPr>
+      <p:sp>
+        <p:nvSpPr>
+          <p:cNvPr id="2" name="Slide Image Placeholder 1"/>
+          <p:cNvSpPr>
+            <a:spLocks noGrp="1"/>
+          </p:cNvSpPr>
+          <p:nvPr>
+            <p:ph type="sldImg" idx="2"/>
+          </p:nvPr>
+        </p:nvSpPr>
+        <p:spPr/>
+      </p:sp>
+      <p:sp>
+        <p:nvSpPr>
+          <p:cNvPr id="3" name="Notes Placeholder 2"/>
+          <p:cNvSpPr>
+            <a:spLocks noGrp="1"/>
+          </p:cNvSpPr>
+          <p:nvPr>
+            <p:ph type="body" idx="3" sz="quarter"/>
+          </p:nvPr>
+        </p:nvSpPr>
+        <p:spPr/>
+        <p:txBody>
+          <a:bodyPr/>
+          <a:lstStyle/>
+          <a:p>
+            <a:r>
+              <a:t>The RLHF loop: customer star rating → feedback_collector → analyse_feedback() → EMPATHY_PREFIX injected into next session.</a:t>
+            </a:r>
+          </a:p>
+          <a:p>
+            <a:r>
+              <a:t>When average rating over the last 20 sessions drops below 0.60, the EMPATHY_PREFIX is prepended to the system prompt — no fine-tuning needed.</a:t>
+            </a:r>
+          </a:p>
+          <a:p>
+            <a:r>
+              <a:t>policy_checker runs on every single response: checks no-approval-guarantee, no-single-rate-promise, no-PII-in-response.</a:t>
+            </a:r>
+          </a:p>
+          <a:p>
+            <a:r>
+              <a:t>RM Dashboard (right) provides the RM with a pending queue, resolved case management, KPI strip, and PII-masked interaction log.</a:t>
+            </a:r>
+          </a:p>
+          <a:p>
+            <a:r>
+              <a:t>This demonstrates a lightweight, auditable RLHF loop — fast to iterate, visible to reviewers, no model weights changed.</a:t>
+            </a:r>
+          </a:p>
+        </p:txBody>
+      </p:sp>
+      <p:sp>
+        <p:nvSpPr>
+          <p:cNvPr id="4" name="Slide Number Placeholder 3"/>
+          <p:cNvSpPr>
+            <a:spLocks noGrp="1"/>
+          </p:cNvSpPr>
+          <p:nvPr>
+            <p:ph type="sldNum" idx="5" sz="quarter"/>
+          </p:nvPr>
+        </p:nvSpPr>
+        <p:spPr/>
+      </p:sp>
+    </p:spTree>
+  </p:cSld>
+  <p:clrMapOvr>
+    <a:masterClrMapping/>
+  </p:clrMapOvr>
+</p:notes>
+</file>
+
+<file path=ppt/notesSlides/notesSlide12.xml><?xml version="1.0" encoding="utf-8"?>
+<p:notes xmlns:a="http://schemas.openxmlformats.org/drawingml/2006/main" xmlns:p="http://schemas.openxmlformats.org/presentationml/2006/main" xmlns:r="http://schemas.openxmlformats.org/officeDocument/2006/relationships">
+  <p:cSld>
+    <p:spTree>
+      <p:nvGrpSpPr>
+        <p:cNvPr id="1" name=""/>
+        <p:cNvGrpSpPr/>
+        <p:nvPr/>
+      </p:nvGrpSpPr>
+      <p:grpSpPr>
+        <a:xfrm>
+          <a:off x="0" y="0"/>
+          <a:ext cx="0" cy="0"/>
+          <a:chOff x="0" y="0"/>
+          <a:chExt cx="0" cy="0"/>
+        </a:xfrm>
+      </p:grpSpPr>
+      <p:sp>
+        <p:nvSpPr>
+          <p:cNvPr id="2" name="Slide Image Placeholder 1"/>
+          <p:cNvSpPr>
+            <a:spLocks noGrp="1"/>
+          </p:cNvSpPr>
+          <p:nvPr>
+            <p:ph type="sldImg" idx="2"/>
+          </p:nvPr>
+        </p:nvSpPr>
+        <p:spPr/>
+      </p:sp>
+      <p:sp>
+        <p:nvSpPr>
+          <p:cNvPr id="3" name="Notes Placeholder 2"/>
+          <p:cNvSpPr>
+            <a:spLocks noGrp="1"/>
+          </p:cNvSpPr>
+          <p:nvPr>
+            <p:ph type="body" idx="3" sz="quarter"/>
+          </p:nvPr>
+        </p:nvSpPr>
+        <p:spPr/>
+        <p:txBody>
+          <a:bodyPr/>
+          <a:lstStyle/>
+          <a:p>
+            <a:r>
+              <a:t>Langfuse self-hosted (Docker Compose, localhost:3000) — zero cloud upload; satisfies Indian data-protection requirements.</a:t>
+            </a:r>
+          </a:p>
+          <a:p>
+            <a:r>
+              <a:t>One Langfuse trace per agent turn captures everything: session_id, tool names + args + outputs, token count, wall-clock latency.</a:t>
+            </a:r>
+          </a:p>
+          <a:p>
+            <a:r>
+              <a:t>Two evaluation datasets: prompt_comparison_5q (15 traces: V1×5, V2×5, V3×5) and rag_eval_20q (20 Q/A pairs for RAG quality).</a:t>
+            </a:r>
+          </a:p>
+          <a:p>
+            <a:r>
+              <a:t>LLM-as-judge scores all evaluation runs 0–1; V3 selected as SYSTEM_PROMPT default based on Q3 (safety boundary) + Q1/Q4 accuracy.</a:t>
+            </a:r>
+          </a:p>
+          <a:p>
+            <a:r>
+              <a:t>Star ratings (user_feedback score) and policy_checker violations (policy_compliance score) both flow to Langfuse for trend analysis.</a:t>
+            </a:r>
+          </a:p>
+        </p:txBody>
+      </p:sp>
+      <p:sp>
+        <p:nvSpPr>
+          <p:cNvPr id="4" name="Slide Number Placeholder 3"/>
+          <p:cNvSpPr>
+            <a:spLocks noGrp="1"/>
+          </p:cNvSpPr>
+          <p:nvPr>
+            <p:ph type="sldNum" idx="5" sz="quarter"/>
+          </p:nvPr>
+        </p:nvSpPr>
+        <p:spPr/>
+      </p:sp>
+    </p:spTree>
+  </p:cSld>
+  <p:clrMapOvr>
+    <a:masterClrMapping/>
+  </p:clrMapOvr>
+</p:notes>
+</file>
+
+<file path=ppt/notesSlides/notesSlide13.xml><?xml version="1.0" encoding="utf-8"?>
+<p:notes xmlns:a="http://schemas.openxmlformats.org/drawingml/2006/main" xmlns:p="http://schemas.openxmlformats.org/presentationml/2006/main" xmlns:r="http://schemas.openxmlformats.org/officeDocument/2006/relationships">
+  <p:cSld>
+    <p:spTree>
+      <p:nvGrpSpPr>
+        <p:cNvPr id="1" name=""/>
+        <p:cNvGrpSpPr/>
+        <p:nvPr/>
+      </p:nvGrpSpPr>
+      <p:grpSpPr>
+        <a:xfrm>
+          <a:off x="0" y="0"/>
+          <a:ext cx="0" cy="0"/>
+          <a:chOff x="0" y="0"/>
+          <a:chExt cx="0" cy="0"/>
+        </a:xfrm>
+      </p:grpSpPr>
+      <p:sp>
+        <p:nvSpPr>
+          <p:cNvPr id="2" name="Slide Image Placeholder 1"/>
+          <p:cNvSpPr>
+            <a:spLocks noGrp="1"/>
+          </p:cNvSpPr>
+          <p:nvPr>
+            <p:ph type="sldImg" idx="2"/>
+          </p:nvPr>
+        </p:nvSpPr>
+        <p:spPr/>
+      </p:sp>
+      <p:sp>
+        <p:nvSpPr>
+          <p:cNvPr id="3" name="Notes Placeholder 2"/>
+          <p:cNvSpPr>
+            <a:spLocks noGrp="1"/>
+          </p:cNvSpPr>
+          <p:nvPr>
+            <p:ph type="body" idx="3" sz="quarter"/>
+          </p:nvPr>
+        </p:nvSpPr>
+        <p:spPr/>
+        <p:txBody>
+          <a:bodyPr/>
+          <a:lstStyle/>
+          <a:p>
+            <a:r>
+              <a:t>3 prompt variants evaluated on 5 standard questions via Langfuse LLM-as-judge — 15 total traces.</a:t>
+            </a:r>
+          </a:p>
+          <a:p>
+            <a:r>
+              <a:t>V1 (~60 tokens): no safety rules, approval language risk — useful only as a baseline.</a:t>
+            </a:r>
+          </a:p>
+          <a:p>
+            <a:r>
+              <a:t>V2 (~200 tokens): adds ROLE + BOUNDARIES but still lacks an explicit SAFETY block — V3 catches cases V2 misses.</a:t>
+            </a:r>
+          </a:p>
+          <a:p>
+            <a:r>
+              <a:t>V3 (~900 tokens, 6 sections): adds SAFETY RULES, rate-range enforcement, product inference from purpose, AMBIGUOUS handling.</a:t>
+            </a:r>
+          </a:p>
+          <a:p>
+            <a:r>
+              <a:t>Q3 (approval guarantee) was the most discriminating test — V1 partially complies, V2 is borderline, V3 gives a clean refusal with no equivocation.</a:t>
+            </a:r>
+          </a:p>
+        </p:txBody>
+      </p:sp>
+      <p:sp>
+        <p:nvSpPr>
+          <p:cNvPr id="4" name="Slide Number Placeholder 3"/>
+          <p:cNvSpPr>
+            <a:spLocks noGrp="1"/>
+          </p:cNvSpPr>
+          <p:nvPr>
+            <p:ph type="sldNum" idx="5" sz="quarter"/>
+          </p:nvPr>
+        </p:nvSpPr>
+        <p:spPr/>
+      </p:sp>
+    </p:spTree>
+  </p:cSld>
+  <p:clrMapOvr>
+    <a:masterClrMapping/>
+  </p:clrMapOvr>
+</p:notes>
+</file>
+
+<file path=ppt/notesSlides/notesSlide14.xml><?xml version="1.0" encoding="utf-8"?>
+<p:notes xmlns:a="http://schemas.openxmlformats.org/drawingml/2006/main" xmlns:p="http://schemas.openxmlformats.org/presentationml/2006/main" xmlns:r="http://schemas.openxmlformats.org/officeDocument/2006/relationships">
+  <p:cSld>
+    <p:spTree>
+      <p:nvGrpSpPr>
+        <p:cNvPr id="1" name=""/>
+        <p:cNvGrpSpPr/>
+        <p:nvPr/>
+      </p:nvGrpSpPr>
+      <p:grpSpPr>
+        <a:xfrm>
+          <a:off x="0" y="0"/>
+          <a:ext cx="0" cy="0"/>
+          <a:chOff x="0" y="0"/>
+          <a:chExt cx="0" cy="0"/>
+        </a:xfrm>
+      </p:grpSpPr>
+      <p:sp>
+        <p:nvSpPr>
+          <p:cNvPr id="2" name="Slide Image Placeholder 1"/>
+          <p:cNvSpPr>
+            <a:spLocks noGrp="1"/>
+          </p:cNvSpPr>
+          <p:nvPr>
+            <p:ph type="sldImg" idx="2"/>
+          </p:nvPr>
+        </p:nvSpPr>
+        <p:spPr/>
+      </p:sp>
+      <p:sp>
+        <p:nvSpPr>
+          <p:cNvPr id="3" name="Notes Placeholder 2"/>
+          <p:cNvSpPr>
+            <a:spLocks noGrp="1"/>
+          </p:cNvSpPr>
+          <p:nvPr>
+            <p:ph type="body" idx="3" sz="quarter"/>
+          </p:nvPr>
+        </p:nvSpPr>
+        <p:spPr/>
+        <p:txBody>
+          <a:bodyPr/>
+          <a:lstStyle/>
+          <a:p>
+            <a:r>
+              <a:t>3 evaluation suites: RAG Quality (20 Q/A pairs, LLM-as-judge), Tool Selection (30 scenarios, boolean match), Safety (5 adversarial probes, must be 100%).</a:t>
+            </a:r>
+          </a:p>
+          <a:p>
+            <a:r>
+              <a:t>RAG target ≥70% pass rate; Tool Selection target ≥80%; Safety must hit 100% — any missed block triggers a full suite re-run.</a:t>
+            </a:r>
+          </a:p>
+          <a:p>
+            <a:r>
+              <a:t>Root-cause investigation: a chunk without the product-label prefix scored 0.4 (retrieved wrong product); adding the prefix → score 1.0.</a:t>
+            </a:r>
+          </a:p>
+          <a:p>
+            <a:r>
+              <a:t>Latency profile shows safety gate handles blocked turns in &lt;200ms; full 4-tool advisory turn takes 3.5–5.0s P50.</a:t>
+            </a:r>
+          </a:p>
+          <a:p>
+            <a:r>
+              <a:t>233 automated tests provide regression coverage; scripts/run_evaluation.py --suite all runs all 3 evaluation suites.</a:t>
+            </a:r>
+          </a:p>
+        </p:txBody>
+      </p:sp>
+      <p:sp>
+        <p:nvSpPr>
+          <p:cNvPr id="4" name="Slide Number Placeholder 3"/>
+          <p:cNvSpPr>
+            <a:spLocks noGrp="1"/>
+          </p:cNvSpPr>
+          <p:nvPr>
+            <p:ph type="sldNum" idx="5" sz="quarter"/>
+          </p:nvPr>
+        </p:nvSpPr>
+        <p:spPr/>
+      </p:sp>
+    </p:spTree>
+  </p:cSld>
+  <p:clrMapOvr>
+    <a:masterClrMapping/>
+  </p:clrMapOvr>
+</p:notes>
+</file>
+
+<file path=ppt/notesSlides/notesSlide15.xml><?xml version="1.0" encoding="utf-8"?>
+<p:notes xmlns:a="http://schemas.openxmlformats.org/drawingml/2006/main" xmlns:p="http://schemas.openxmlformats.org/presentationml/2006/main" xmlns:r="http://schemas.openxmlformats.org/officeDocument/2006/relationships">
+  <p:cSld>
+    <p:spTree>
+      <p:nvGrpSpPr>
+        <p:cNvPr id="1" name=""/>
+        <p:cNvGrpSpPr/>
+        <p:nvPr/>
+      </p:nvGrpSpPr>
+      <p:grpSpPr>
+        <a:xfrm>
+          <a:off x="0" y="0"/>
+          <a:ext cx="0" cy="0"/>
+          <a:chOff x="0" y="0"/>
+          <a:chExt cx="0" cy="0"/>
+        </a:xfrm>
+      </p:grpSpPr>
+      <p:sp>
+        <p:nvSpPr>
+          <p:cNvPr id="2" name="Slide Image Placeholder 1"/>
+          <p:cNvSpPr>
+            <a:spLocks noGrp="1"/>
+          </p:cNvSpPr>
+          <p:nvPr>
+            <p:ph type="sldImg" idx="2"/>
+          </p:nvPr>
+        </p:nvSpPr>
+        <p:spPr/>
+      </p:sp>
+      <p:sp>
+        <p:nvSpPr>
+          <p:cNvPr id="3" name="Notes Placeholder 2"/>
+          <p:cNvSpPr>
+            <a:spLocks noGrp="1"/>
+          </p:cNvSpPr>
+          <p:nvPr>
+            <p:ph type="body" idx="3" sz="quarter"/>
+          </p:nvPr>
+        </p:nvSpPr>
+        <p:spPr/>
+        <p:txBody>
+          <a:bodyPr/>
+          <a:lstStyle/>
+          <a:p>
+            <a:r>
+              <a:t>Baseline: 2,500 RM-hours/month on pre-screening × ₹600/hr loaded cost = ₹15 Lakh/month.</a:t>
+            </a:r>
+          </a:p>
+          <a:p>
+            <a:r>
+              <a:t>The copilot automates 65% of queries → RM residual drops to 875 hrs/month → ₹5.25L/month. Monthly savings: ₹9.75L.</a:t>
+            </a:r>
+          </a:p>
+          <a:p>
+            <a:r>
+              <a:t>Annual savings: ₹1.17 Crore. Estimated 3-month production dev cost ~₹25–30L → payback in under 6 months.</a:t>
+            </a:r>
+          </a:p>
+          <a:p>
+            <a:r>
+              <a:t>Beyond cost: zero lead loss (structured escalation packets), 24×7 availability, infinite scale, consistent policy compliance.</a:t>
+            </a:r>
+          </a:p>
+          <a:p>
+            <a:r>
+              <a:t>These are conservative assumptions — actual ROI will be higher with scale and as the copilot handles increasingly complex queries over time.</a:t>
+            </a:r>
+          </a:p>
+        </p:txBody>
+      </p:sp>
+      <p:sp>
+        <p:nvSpPr>
+          <p:cNvPr id="4" name="Slide Number Placeholder 3"/>
+          <p:cNvSpPr>
+            <a:spLocks noGrp="1"/>
+          </p:cNvSpPr>
+          <p:nvPr>
+            <p:ph type="sldNum" idx="5" sz="quarter"/>
+          </p:nvPr>
+        </p:nvSpPr>
+        <p:spPr/>
+      </p:sp>
+    </p:spTree>
+  </p:cSld>
+  <p:clrMapOvr>
+    <a:masterClrMapping/>
+  </p:clrMapOvr>
+</p:notes>
+</file>
+
+<file path=ppt/notesSlides/notesSlide16.xml><?xml version="1.0" encoding="utf-8"?>
+<p:notes xmlns:a="http://schemas.openxmlformats.org/drawingml/2006/main" xmlns:p="http://schemas.openxmlformats.org/presentationml/2006/main" xmlns:r="http://schemas.openxmlformats.org/officeDocument/2006/relationships">
+  <p:cSld>
+    <p:spTree>
+      <p:nvGrpSpPr>
+        <p:cNvPr id="1" name=""/>
+        <p:cNvGrpSpPr/>
+        <p:nvPr/>
+      </p:nvGrpSpPr>
+      <p:grpSpPr>
+        <a:xfrm>
+          <a:off x="0" y="0"/>
+          <a:ext cx="0" cy="0"/>
+          <a:chOff x="0" y="0"/>
+          <a:chExt cx="0" cy="0"/>
+        </a:xfrm>
+      </p:grpSpPr>
+      <p:sp>
+        <p:nvSpPr>
+          <p:cNvPr id="2" name="Slide Image Placeholder 1"/>
+          <p:cNvSpPr>
+            <a:spLocks noGrp="1"/>
+          </p:cNvSpPr>
+          <p:nvPr>
+            <p:ph type="sldImg" idx="2"/>
+          </p:nvPr>
+        </p:nvSpPr>
+        <p:spPr/>
+      </p:sp>
+      <p:sp>
+        <p:nvSpPr>
+          <p:cNvPr id="3" name="Notes Placeholder 2"/>
+          <p:cNvSpPr>
+            <a:spLocks noGrp="1"/>
+          </p:cNvSpPr>
+          <p:nvPr>
+            <p:ph type="body" idx="3" sz="quarter"/>
+          </p:nvPr>
+        </p:nvSpPr>
+        <p:spPr/>
+        <p:txBody>
+          <a:bodyPr/>
+          <a:lstStyle/>
+          <a:p>
+            <a:r>
+              <a:t>5 key learnings from this capstone project.</a:t>
+            </a:r>
+          </a:p>
+          <a:p>
+            <a:r>
+              <a:t>1. ReAct + typed tools: structured JSON schemas gave reliable orchestration with minimal prompt engineering for flow logic.</a:t>
+            </a:r>
+          </a:p>
+          <a:p>
+            <a:r>
+              <a:t>2. Product-label prefix: the highest-impact single fix — data quality beat model tuning; precision went from 45% to ≥70%.</a:t>
+            </a:r>
+          </a:p>
+          <a:p>
+            <a:r>
+              <a:t>3. Safety first-class: two-stage gate + PII masking before every log write are architectural constraints, not optional features.</a:t>
+            </a:r>
+          </a:p>
+          <a:p>
+            <a:r>
+              <a:t>4. Langfuse self-hosted: one decision solved both the tracing need and the data-privacy requirement simultaneously.</a:t>
+            </a:r>
+          </a:p>
+          <a:p>
+            <a:r>
+              <a:t>5. Prompt-level RLHF: EMPATHY_PREFIX injection demonstrates a lightweight feedback loop — fast to iterate, fully auditable, no fine-tuning needed.</a:t>
+            </a:r>
+          </a:p>
+          <a:p>
+            <a:r>
+              <a:t>Happy to take questions — I have demo notebooks for any phase you'd like to explore further.</a:t>
+            </a:r>
+          </a:p>
+        </p:txBody>
+      </p:sp>
+      <p:sp>
+        <p:nvSpPr>
+          <p:cNvPr id="4" name="Slide Number Placeholder 3"/>
+          <p:cNvSpPr>
+            <a:spLocks noGrp="1"/>
+          </p:cNvSpPr>
+          <p:nvPr>
+            <p:ph type="sldNum" idx="5" sz="quarter"/>
+          </p:nvPr>
+        </p:nvSpPr>
+        <p:spPr/>
+      </p:sp>
+    </p:spTree>
+  </p:cSld>
+  <p:clrMapOvr>
+    <a:masterClrMapping/>
+  </p:clrMapOvr>
+</p:notes>
+</file>
+
+<file path=ppt/notesSlides/notesSlide2.xml><?xml version="1.0" encoding="utf-8"?>
+<p:notes xmlns:a="http://schemas.openxmlformats.org/drawingml/2006/main" xmlns:p="http://schemas.openxmlformats.org/presentationml/2006/main" xmlns:r="http://schemas.openxmlformats.org/officeDocument/2006/relationships">
+  <p:cSld>
+    <p:spTree>
+      <p:nvGrpSpPr>
+        <p:cNvPr id="1" name=""/>
+        <p:cNvGrpSpPr/>
+        <p:nvPr/>
+      </p:nvGrpSpPr>
+      <p:grpSpPr>
+        <a:xfrm>
+          <a:off x="0" y="0"/>
+          <a:ext cx="0" cy="0"/>
+          <a:chOff x="0" y="0"/>
+          <a:chExt cx="0" cy="0"/>
+        </a:xfrm>
+      </p:grpSpPr>
+      <p:sp>
+        <p:nvSpPr>
+          <p:cNvPr id="2" name="Slide Image Placeholder 1"/>
+          <p:cNvSpPr>
+            <a:spLocks noGrp="1"/>
+          </p:cNvSpPr>
+          <p:nvPr>
+            <p:ph type="sldImg" idx="2"/>
+          </p:nvPr>
+        </p:nvSpPr>
+        <p:spPr/>
+      </p:sp>
+      <p:sp>
+        <p:nvSpPr>
+          <p:cNvPr id="3" name="Notes Placeholder 2"/>
+          <p:cNvSpPr>
+            <a:spLocks noGrp="1"/>
+          </p:cNvSpPr>
+          <p:nvPr>
+            <p:ph type="body" idx="3" sz="quarter"/>
+          </p:nvPr>
+        </p:nvSpPr>
+        <p:spPr/>
+        <p:txBody>
+          <a:bodyPr/>
+          <a:lstStyle/>
+          <a:p>
+            <a:r>
+              <a:t>Indian retail banks lose ~2,500 RM-hours every month to repeatable pre-screening queries.</a:t>
+            </a:r>
+          </a:p>
+          <a:p>
+            <a:r>
+              <a:t>60% of loan enquiries are rejected at eligibility stage — yet RMs still spend 25–40 min per customer on cases that go nowhere.</a:t>
+            </a:r>
+          </a:p>
+          <a:p>
+            <a:r>
+              <a:t>4 products × 4 rulesets creates inconsistency risk — different RMs give different answers, a compliance problem.</a:t>
+            </a:r>
+          </a:p>
+          <a:p>
+            <a:r>
+              <a:t>Customers can only reach an RM 9am–6pm Mon–Sat; loan enquiries arrive 24×7.</a:t>
+            </a:r>
+          </a:p>
+          <a:p>
+            <a:r>
+              <a:t>The AI opportunity: 65% of these queries are automatable — eligibility, EMI, docs, FAQ — freeing RMs for complex cases.</a:t>
+            </a:r>
+          </a:p>
+        </p:txBody>
+      </p:sp>
+      <p:sp>
+        <p:nvSpPr>
+          <p:cNvPr id="4" name="Slide Number Placeholder 3"/>
+          <p:cNvSpPr>
+            <a:spLocks noGrp="1"/>
+          </p:cNvSpPr>
+          <p:nvPr>
+            <p:ph type="sldNum" idx="5" sz="quarter"/>
+          </p:nvPr>
+        </p:nvSpPr>
+        <p:spPr/>
+      </p:sp>
+    </p:spTree>
+  </p:cSld>
+  <p:clrMapOvr>
+    <a:masterClrMapping/>
+  </p:clrMapOvr>
+</p:notes>
+</file>
+
+<file path=ppt/notesSlides/notesSlide3.xml><?xml version="1.0" encoding="utf-8"?>
+<p:notes xmlns:a="http://schemas.openxmlformats.org/drawingml/2006/main" xmlns:p="http://schemas.openxmlformats.org/presentationml/2006/main" xmlns:r="http://schemas.openxmlformats.org/officeDocument/2006/relationships">
+  <p:cSld>
+    <p:spTree>
+      <p:nvGrpSpPr>
+        <p:cNvPr id="1" name=""/>
+        <p:cNvGrpSpPr/>
+        <p:nvPr/>
+      </p:nvGrpSpPr>
+      <p:grpSpPr>
+        <a:xfrm>
+          <a:off x="0" y="0"/>
+          <a:ext cx="0" cy="0"/>
+          <a:chOff x="0" y="0"/>
+          <a:chExt cx="0" cy="0"/>
+        </a:xfrm>
+      </p:grpSpPr>
+      <p:sp>
+        <p:nvSpPr>
+          <p:cNvPr id="2" name="Slide Image Placeholder 1"/>
+          <p:cNvSpPr>
+            <a:spLocks noGrp="1"/>
+          </p:cNvSpPr>
+          <p:nvPr>
+            <p:ph type="sldImg" idx="2"/>
+          </p:nvPr>
+        </p:nvSpPr>
+        <p:spPr/>
+      </p:sp>
+      <p:sp>
+        <p:nvSpPr>
+          <p:cNvPr id="3" name="Notes Placeholder 2"/>
+          <p:cNvSpPr>
+            <a:spLocks noGrp="1"/>
+          </p:cNvSpPr>
+          <p:nvPr>
+            <p:ph type="body" idx="3" sz="quarter"/>
+          </p:nvPr>
+        </p:nvSpPr>
+        <p:spPr/>
+        <p:txBody>
+          <a:bodyPr/>
+          <a:lstStyle/>
+          <a:p>
+            <a:r>
+              <a:t>The copilot delivers 5 tightly integrated capabilities covering the full pre-application journey.</a:t>
+            </a:r>
+          </a:p>
+          <a:p>
+            <a:r>
+              <a:t>Eligibility check uses FOIR (fixed obligations to income ratio) + credit score + age + amount limits — returns PASS / REFER / REJECT with a specific reason.</a:t>
+            </a:r>
+          </a:p>
+          <a:p>
+            <a:r>
+              <a:t>EMI is calculated using reducing-balance formula; always presented as a range (min rate to max rate) with an indicative disclaimer.</a:t>
+            </a:r>
+          </a:p>
+          <a:p>
+            <a:r>
+              <a:t>Document checklist is a product × employment-type lookup — tailored to each customer's situation.</a:t>
+            </a:r>
+          </a:p>
+          <a:p>
+            <a:r>
+              <a:t>The sample conversation shows how all 4 capabilities fire in sequence in just 3 turns for a salaried Home Loan customer.</a:t>
+            </a:r>
+          </a:p>
+        </p:txBody>
+      </p:sp>
+      <p:sp>
+        <p:nvSpPr>
+          <p:cNvPr id="4" name="Slide Number Placeholder 3"/>
+          <p:cNvSpPr>
+            <a:spLocks noGrp="1"/>
+          </p:cNvSpPr>
+          <p:nvPr>
+            <p:ph type="sldNum" idx="5" sz="quarter"/>
+          </p:nvPr>
+        </p:nvSpPr>
+        <p:spPr/>
+      </p:sp>
+    </p:spTree>
+  </p:cSld>
+  <p:clrMapOvr>
+    <a:masterClrMapping/>
+  </p:clrMapOvr>
+</p:notes>
+</file>
+
+<file path=ppt/notesSlides/notesSlide4.xml><?xml version="1.0" encoding="utf-8"?>
+<p:notes xmlns:a="http://schemas.openxmlformats.org/drawingml/2006/main" xmlns:p="http://schemas.openxmlformats.org/presentationml/2006/main" xmlns:r="http://schemas.openxmlformats.org/officeDocument/2006/relationships">
+  <p:cSld>
+    <p:spTree>
+      <p:nvGrpSpPr>
+        <p:cNvPr id="1" name=""/>
+        <p:cNvGrpSpPr/>
+        <p:nvPr/>
+      </p:nvGrpSpPr>
+      <p:grpSpPr>
+        <a:xfrm>
+          <a:off x="0" y="0"/>
+          <a:ext cx="0" cy="0"/>
+          <a:chOff x="0" y="0"/>
+          <a:chExt cx="0" cy="0"/>
+        </a:xfrm>
+      </p:grpSpPr>
+      <p:sp>
+        <p:nvSpPr>
+          <p:cNvPr id="2" name="Slide Image Placeholder 1"/>
+          <p:cNvSpPr>
+            <a:spLocks noGrp="1"/>
+          </p:cNvSpPr>
+          <p:nvPr>
+            <p:ph type="sldImg" idx="2"/>
+          </p:nvPr>
+        </p:nvSpPr>
+        <p:spPr/>
+      </p:sp>
+      <p:sp>
+        <p:nvSpPr>
+          <p:cNvPr id="3" name="Notes Placeholder 2"/>
+          <p:cNvSpPr>
+            <a:spLocks noGrp="1"/>
+          </p:cNvSpPr>
+          <p:nvPr>
+            <p:ph type="body" idx="3" sz="quarter"/>
+          </p:nvPr>
+        </p:nvSpPr>
+        <p:spPr/>
+        <p:txBody>
+          <a:bodyPr/>
+          <a:lstStyle/>
+          <a:p>
+            <a:r>
+              <a:t>5 layers — Presentation → Safety Gate → Agent/Orchestration → Tools → Retrieval — all traced through Langfuse.</a:t>
+            </a:r>
+          </a:p>
+          <a:p>
+            <a:r>
+              <a:t>Users interact via Streamlit customer chat, RM dashboard, or CLI; every message passes through the 2-stage safety gate first.</a:t>
+            </a:r>
+          </a:p>
+          <a:p>
+            <a:r>
+              <a:t>The ReAct agent (GPT-4o) sits at the centre — it reasons about what the user needs and selects the right tool with JSON args.</a:t>
+            </a:r>
+          </a:p>
+          <a:p>
+            <a:r>
+              <a:t>Layer ④ shows the 5 @tool functions; Layer ⑤ shows the full RAG ingestion pipeline ending in ChromaDB.</a:t>
+            </a:r>
+          </a:p>
+          <a:p>
+            <a:r>
+              <a:t>Langfuse (right panel) is self-hosted — all traces stay on-premise, satisfying Indian data-protection requirements.</a:t>
+            </a:r>
+          </a:p>
+        </p:txBody>
+      </p:sp>
+      <p:sp>
+        <p:nvSpPr>
+          <p:cNvPr id="4" name="Slide Number Placeholder 3"/>
+          <p:cNvSpPr>
+            <a:spLocks noGrp="1"/>
+          </p:cNvSpPr>
+          <p:nvPr>
+            <p:ph type="sldNum" idx="5" sz="quarter"/>
+          </p:nvPr>
+        </p:nvSpPr>
+        <p:spPr/>
+      </p:sp>
+    </p:spTree>
+  </p:cSld>
+  <p:clrMapOvr>
+    <a:masterClrMapping/>
+  </p:clrMapOvr>
+</p:notes>
+</file>
+
+<file path=ppt/notesSlides/notesSlide5.xml><?xml version="1.0" encoding="utf-8"?>
+<p:notes xmlns:a="http://schemas.openxmlformats.org/drawingml/2006/main" xmlns:p="http://schemas.openxmlformats.org/presentationml/2006/main" xmlns:r="http://schemas.openxmlformats.org/officeDocument/2006/relationships">
+  <p:cSld>
+    <p:spTree>
+      <p:nvGrpSpPr>
+        <p:cNvPr id="1" name=""/>
+        <p:cNvGrpSpPr/>
+        <p:nvPr/>
+      </p:nvGrpSpPr>
+      <p:grpSpPr>
+        <a:xfrm>
+          <a:off x="0" y="0"/>
+          <a:ext cx="0" cy="0"/>
+          <a:chOff x="0" y="0"/>
+          <a:chExt cx="0" cy="0"/>
+        </a:xfrm>
+      </p:grpSpPr>
+      <p:sp>
+        <p:nvSpPr>
+          <p:cNvPr id="2" name="Slide Image Placeholder 1"/>
+          <p:cNvSpPr>
+            <a:spLocks noGrp="1"/>
+          </p:cNvSpPr>
+          <p:nvPr>
+            <p:ph type="sldImg" idx="2"/>
+          </p:nvPr>
+        </p:nvSpPr>
+        <p:spPr/>
+      </p:sp>
+      <p:sp>
+        <p:nvSpPr>
+          <p:cNvPr id="3" name="Notes Placeholder 2"/>
+          <p:cNvSpPr>
+            <a:spLocks noGrp="1"/>
+          </p:cNvSpPr>
+          <p:nvPr>
+            <p:ph type="body" idx="3" sz="quarter"/>
+          </p:nvPr>
+        </p:nvSpPr>
+        <p:spPr/>
+        <p:txBody>
+          <a:bodyPr/>
+          <a:lstStyle/>
+          <a:p>
+            <a:r>
+              <a:t>Every tech choice has a documented justification in docs/engineering_justification.md — this slide is the summary.</a:t>
+            </a:r>
+          </a:p>
+          <a:p>
+            <a:r>
+              <a:t>GPT-4o chosen for tool-calling fidelity; GPT-4o-mini for safety gate (&lt;50 tokens, &lt;150ms, minimal cost overhead).</a:t>
+            </a:r>
+          </a:p>
+          <a:p>
+            <a:r>
+              <a:t>ReAct over Plan-and-Execute: loan advisory is a sequential, deterministic flow — a separate planner adds 300ms with no accuracy benefit.</a:t>
+            </a:r>
+          </a:p>
+          <a:p>
+            <a:r>
+              <a:t>Langfuse self-hosted: LangSmith is cloud-only — banking income and employment data cannot leave the network perimeter (India data-protection).</a:t>
+            </a:r>
+          </a:p>
+          <a:p>
+            <a:r>
+              <a:t>ChromaDB persistent with metadata filtering: FAISS migration path documented; text-embedding-3-small chosen for cost/quality ratio.</a:t>
+            </a:r>
+          </a:p>
+        </p:txBody>
+      </p:sp>
+      <p:sp>
+        <p:nvSpPr>
+          <p:cNvPr id="4" name="Slide Number Placeholder 3"/>
+          <p:cNvSpPr>
+            <a:spLocks noGrp="1"/>
+          </p:cNvSpPr>
+          <p:nvPr>
+            <p:ph type="sldNum" idx="5" sz="quarter"/>
+          </p:nvPr>
+        </p:nvSpPr>
+        <p:spPr/>
+      </p:sp>
+    </p:spTree>
+  </p:cSld>
+  <p:clrMapOvr>
+    <a:masterClrMapping/>
+  </p:clrMapOvr>
+</p:notes>
+</file>
+
+<file path=ppt/notesSlides/notesSlide6.xml><?xml version="1.0" encoding="utf-8"?>
+<p:notes xmlns:a="http://schemas.openxmlformats.org/drawingml/2006/main" xmlns:p="http://schemas.openxmlformats.org/presentationml/2006/main" xmlns:r="http://schemas.openxmlformats.org/officeDocument/2006/relationships">
+  <p:cSld>
+    <p:spTree>
+      <p:nvGrpSpPr>
+        <p:cNvPr id="1" name=""/>
+        <p:cNvGrpSpPr/>
+        <p:nvPr/>
+      </p:nvGrpSpPr>
+      <p:grpSpPr>
+        <a:xfrm>
+          <a:off x="0" y="0"/>
+          <a:ext cx="0" cy="0"/>
+          <a:chOff x="0" y="0"/>
+          <a:chExt cx="0" cy="0"/>
+        </a:xfrm>
+      </p:grpSpPr>
+      <p:sp>
+        <p:nvSpPr>
+          <p:cNvPr id="2" name="Slide Image Placeholder 1"/>
+          <p:cNvSpPr>
+            <a:spLocks noGrp="1"/>
+          </p:cNvSpPr>
+          <p:nvPr>
+            <p:ph type="sldImg" idx="2"/>
+          </p:nvPr>
+        </p:nvSpPr>
+        <p:spPr/>
+      </p:sp>
+      <p:sp>
+        <p:nvSpPr>
+          <p:cNvPr id="3" name="Notes Placeholder 2"/>
+          <p:cNvSpPr>
+            <a:spLocks noGrp="1"/>
+          </p:cNvSpPr>
+          <p:nvPr>
+            <p:ph type="body" idx="3" sz="quarter"/>
+          </p:nvPr>
+        </p:nvSpPr>
+        <p:spPr/>
+        <p:txBody>
+          <a:bodyPr/>
+          <a:lstStyle/>
+          <a:p>
+            <a:r>
+              <a:t>8 phases built in 10 days — Phase 2 (rules-based, no LLM) through Phase 9 (evaluation).</a:t>
+            </a:r>
+          </a:p>
+          <a:p>
+            <a:r>
+              <a:t>Phases progress: rules → GPT-4o → RAG → tool integration → memory → RLHF → deployment → evaluation.</a:t>
+            </a:r>
+          </a:p>
+          <a:p>
+            <a:r>
+              <a:t>The rubric alignment table (bottom) maps each phase to a graded dimension with evidence and key artifacts.</a:t>
+            </a:r>
+          </a:p>
+          <a:p>
+            <a:r>
+              <a:t>All 8 phases are complete — verified by 233 passing tests and 8 Jupyter demo notebooks.</a:t>
+            </a:r>
+          </a:p>
+          <a:p>
+            <a:r>
+              <a:t>Key milestone: Phase 4 RAG + Phase 5 tools are where the system becomes truly conversational and grounded.</a:t>
+            </a:r>
+          </a:p>
+        </p:txBody>
+      </p:sp>
+      <p:sp>
+        <p:nvSpPr>
+          <p:cNvPr id="4" name="Slide Number Placeholder 3"/>
+          <p:cNvSpPr>
+            <a:spLocks noGrp="1"/>
+          </p:cNvSpPr>
+          <p:nvPr>
+            <p:ph type="sldNum" idx="5" sz="quarter"/>
+          </p:nvPr>
+        </p:nvSpPr>
+        <p:spPr/>
+      </p:sp>
+    </p:spTree>
+  </p:cSld>
+  <p:clrMapOvr>
+    <a:masterClrMapping/>
+  </p:clrMapOvr>
+</p:notes>
+</file>
+
+<file path=ppt/notesSlides/notesSlide7.xml><?xml version="1.0" encoding="utf-8"?>
+<p:notes xmlns:a="http://schemas.openxmlformats.org/drawingml/2006/main" xmlns:p="http://schemas.openxmlformats.org/presentationml/2006/main" xmlns:r="http://schemas.openxmlformats.org/officeDocument/2006/relationships">
+  <p:cSld>
+    <p:spTree>
+      <p:nvGrpSpPr>
+        <p:cNvPr id="1" name=""/>
+        <p:cNvGrpSpPr/>
+        <p:nvPr/>
+      </p:nvGrpSpPr>
+      <p:grpSpPr>
+        <a:xfrm>
+          <a:off x="0" y="0"/>
+          <a:ext cx="0" cy="0"/>
+          <a:chOff x="0" y="0"/>
+          <a:chExt cx="0" cy="0"/>
+        </a:xfrm>
+      </p:grpSpPr>
+      <p:sp>
+        <p:nvSpPr>
+          <p:cNvPr id="2" name="Slide Image Placeholder 1"/>
+          <p:cNvSpPr>
+            <a:spLocks noGrp="1"/>
+          </p:cNvSpPr>
+          <p:nvPr>
+            <p:ph type="sldImg" idx="2"/>
+          </p:nvPr>
+        </p:nvSpPr>
+        <p:spPr/>
+      </p:sp>
+      <p:sp>
+        <p:nvSpPr>
+          <p:cNvPr id="3" name="Notes Placeholder 2"/>
+          <p:cNvSpPr>
+            <a:spLocks noGrp="1"/>
+          </p:cNvSpPr>
+          <p:nvPr>
+            <p:ph type="body" idx="3" sz="quarter"/>
+          </p:nvPr>
+        </p:nvSpPr>
+        <p:spPr/>
+        <p:txBody>
+          <a:bodyPr/>
+          <a:lstStyle/>
+          <a:p>
+            <a:r>
+              <a:t>The left panel shows the ReAct loop: Think → Act (select tool + JSON args) → Observe result → Loop → Respond.</a:t>
+            </a:r>
+          </a:p>
+          <a:p>
+            <a:r>
+              <a:t>5 @tool functions are registered in tool_registry.py; GPT-4o dynamically selects the right tool based on conversation state.</a:t>
+            </a:r>
+          </a:p>
+          <a:p>
+            <a:r>
+              <a:t>check_eligibility is the most complex: 8 input parameters, product-specific FOIR and credit limits, returns PASS/REFER/REJECT with reason.</a:t>
+            </a:r>
+          </a:p>
+          <a:p>
+            <a:r>
+              <a:t>generate_escalation_summary is triggered automatically when loan_amount exceeds the product ceiling — validates mobile (10-digit) and email.</a:t>
+            </a:r>
+          </a:p>
+          <a:p>
+            <a:r>
+              <a:t>All tool calls are traced in Langfuse with full args + output — crucial for debugging and evaluation.</a:t>
+            </a:r>
+          </a:p>
+        </p:txBody>
+      </p:sp>
+      <p:sp>
+        <p:nvSpPr>
+          <p:cNvPr id="4" name="Slide Number Placeholder 3"/>
+          <p:cNvSpPr>
+            <a:spLocks noGrp="1"/>
+          </p:cNvSpPr>
+          <p:nvPr>
+            <p:ph type="sldNum" idx="5" sz="quarter"/>
+          </p:nvPr>
+        </p:nvSpPr>
+        <p:spPr/>
+      </p:sp>
+    </p:spTree>
+  </p:cSld>
+  <p:clrMapOvr>
+    <a:masterClrMapping/>
+  </p:clrMapOvr>
+</p:notes>
+</file>
+
+<file path=ppt/notesSlides/notesSlide8.xml><?xml version="1.0" encoding="utf-8"?>
+<p:notes xmlns:a="http://schemas.openxmlformats.org/drawingml/2006/main" xmlns:p="http://schemas.openxmlformats.org/presentationml/2006/main" xmlns:r="http://schemas.openxmlformats.org/officeDocument/2006/relationships">
+  <p:cSld>
+    <p:spTree>
+      <p:nvGrpSpPr>
+        <p:cNvPr id="1" name=""/>
+        <p:cNvGrpSpPr/>
+        <p:nvPr/>
+      </p:nvGrpSpPr>
+      <p:grpSpPr>
+        <a:xfrm>
+          <a:off x="0" y="0"/>
+          <a:ext cx="0" cy="0"/>
+          <a:chOff x="0" y="0"/>
+          <a:chExt cx="0" cy="0"/>
+        </a:xfrm>
+      </p:grpSpPr>
+      <p:sp>
+        <p:nvSpPr>
+          <p:cNvPr id="2" name="Slide Image Placeholder 1"/>
+          <p:cNvSpPr>
+            <a:spLocks noGrp="1"/>
+          </p:cNvSpPr>
+          <p:nvPr>
+            <p:ph type="sldImg" idx="2"/>
+          </p:nvPr>
+        </p:nvSpPr>
+        <p:spPr/>
+      </p:sp>
+      <p:sp>
+        <p:nvSpPr>
+          <p:cNvPr id="3" name="Notes Placeholder 2"/>
+          <p:cNvSpPr>
+            <a:spLocks noGrp="1"/>
+          </p:cNvSpPr>
+          <p:nvPr>
+            <p:ph type="body" idx="3" sz="quarter"/>
+          </p:nvPr>
+        </p:nvSpPr>
+        <p:spPr/>
+        <p:txBody>
+          <a:bodyPr/>
+          <a:lstStyle/>
+          <a:p>
+            <a:r>
+              <a:t>5-step RAG pipeline: document_loader → chunker → embedder → ChromaDB store → retriever.</a:t>
+            </a:r>
+          </a:p>
+          <a:p>
+            <a:r>
+              <a:t>Key engineering insight: without the product-label prefix, the MSME docs query retrieved Home Loan chunks — semantic similarity alone is insufficient across similar-domain documents.</a:t>
+            </a:r>
+          </a:p>
+          <a:p>
+            <a:r>
+              <a:t>The fix: prepend '[MSME LOAN] ...' to every chunk from that product file. Retrieval precision jumped from ~45% to ≥70% with zero model changes.</a:t>
+            </a:r>
+          </a:p>
+          <a:p>
+            <a:r>
+              <a:t>500-char chunks with 100-char overlap; text-embedding-3-small (1536-dim); RAG_TOP_K=5 with MMR re-ranking for diversity.</a:t>
+            </a:r>
+          </a:p>
+          <a:p>
+            <a:r>
+              <a:t>Run 'python scripts/ingest_documents.py' after any policy doc update — takes ~30 seconds for all 5 files.</a:t>
+            </a:r>
+          </a:p>
+        </p:txBody>
+      </p:sp>
+      <p:sp>
+        <p:nvSpPr>
+          <p:cNvPr id="4" name="Slide Number Placeholder 3"/>
+          <p:cNvSpPr>
+            <a:spLocks noGrp="1"/>
+          </p:cNvSpPr>
+          <p:nvPr>
+            <p:ph type="sldNum" idx="5" sz="quarter"/>
+          </p:nvPr>
+        </p:nvSpPr>
+        <p:spPr/>
+      </p:sp>
+    </p:spTree>
+  </p:cSld>
+  <p:clrMapOvr>
+    <a:masterClrMapping/>
+  </p:clrMapOvr>
+</p:notes>
+</file>
+
+<file path=ppt/notesSlides/notesSlide9.xml><?xml version="1.0" encoding="utf-8"?>
+<p:notes xmlns:a="http://schemas.openxmlformats.org/drawingml/2006/main" xmlns:p="http://schemas.openxmlformats.org/presentationml/2006/main" xmlns:r="http://schemas.openxmlformats.org/officeDocument/2006/relationships">
+  <p:cSld>
+    <p:spTree>
+      <p:nvGrpSpPr>
+        <p:cNvPr id="1" name=""/>
+        <p:cNvGrpSpPr/>
+        <p:nvPr/>
+      </p:nvGrpSpPr>
+      <p:grpSpPr>
+        <a:xfrm>
+          <a:off x="0" y="0"/>
+          <a:ext cx="0" cy="0"/>
+          <a:chOff x="0" y="0"/>
+          <a:chExt cx="0" cy="0"/>
+        </a:xfrm>
+      </p:grpSpPr>
+      <p:sp>
+        <p:nvSpPr>
+          <p:cNvPr id="2" name="Slide Image Placeholder 1"/>
+          <p:cNvSpPr>
+            <a:spLocks noGrp="1"/>
+          </p:cNvSpPr>
+          <p:nvPr>
+            <p:ph type="sldImg" idx="2"/>
+          </p:nvPr>
+        </p:nvSpPr>
+        <p:spPr/>
+      </p:sp>
+      <p:sp>
+        <p:nvSpPr>
+          <p:cNvPr id="3" name="Notes Placeholder 2"/>
+          <p:cNvSpPr>
+            <a:spLocks noGrp="1"/>
+          </p:cNvSpPr>
+          <p:nvPr>
+            <p:ph type="body" idx="3" sz="quarter"/>
+          </p:nvPr>
+        </p:nvSpPr>
+        <p:spPr/>
+        <p:txBody>
+          <a:bodyPr/>
+          <a:lstStyle/>
+          <a:p>
+            <a:r>
+              <a:t>Two-stage gate sits in front of every agent call — no message reaches GPT-4o until it passes both stages.</a:t>
+            </a:r>
+          </a:p>
+          <a:p>
+            <a:r>
+              <a:t>Stage A (keyword blocklist): catches 80%+ of adversarial probes in under 1ms at zero token cost.</a:t>
+            </a:r>
+          </a:p>
+          <a:p>
+            <a:r>
+              <a:t>Stage B (GPT-4o-mini classifier): handles semantic edge cases; fail-OPEN on API error so legitimate customers are never blocked.</a:t>
+            </a:r>
+          </a:p>
+          <a:p>
+            <a:r>
+              <a:t>PII filter (right panel) is applied before EVERY log write — 5 types, ordered Mobile → Aadhaar → PAN → Email → Account.</a:t>
+            </a:r>
+          </a:p>
+          <a:p>
+            <a:r>
+              <a:t>100% adversarial block rate achieved in evaluation — all 5 probe types blocked correctly.</a:t>
+            </a:r>
+          </a:p>
+        </p:txBody>
+      </p:sp>
+      <p:sp>
+        <p:nvSpPr>
+          <p:cNvPr id="4" name="Slide Number Placeholder 3"/>
+          <p:cNvSpPr>
+            <a:spLocks noGrp="1"/>
+          </p:cNvSpPr>
+          <p:nvPr>
+            <p:ph type="sldNum" idx="5" sz="quarter"/>
+          </p:nvPr>
+        </p:nvSpPr>
+        <p:spPr/>
+      </p:sp>
+    </p:spTree>
+  </p:cSld>
+  <p:clrMapOvr>
+    <a:masterClrMapping/>
+  </p:clrMapOvr>
+</p:notes>
 </file>
 
 <file path=ppt/slideLayouts/slideLayout1.xml><?xml version="1.0" encoding="utf-8"?>
@@ -7436,7 +9231,7 @@
         <p:spPr>
           <a:xfrm>
             <a:off x="7680960" y="4544568"/>
-            <a:ext cx="4297680" cy="3337560"/>
+            <a:ext cx="4297680" cy="2011680"/>
           </a:xfrm>
           <a:prstGeom prst="rect">
             <a:avLst/>
@@ -7558,7 +9353,7 @@
         <p:spPr>
           <a:xfrm>
             <a:off x="7772400" y="4910328"/>
-            <a:ext cx="4114800" cy="658368"/>
+            <a:ext cx="4114800" cy="384048"/>
           </a:xfrm>
           <a:prstGeom prst="rect">
             <a:avLst/>
@@ -7601,22 +9396,22 @@
         <p:spPr>
           <a:xfrm>
             <a:off x="7863840" y="4937760"/>
-            <a:ext cx="1828800" cy="274320"/>
-          </a:xfrm>
-          <a:prstGeom prst="rect">
-            <a:avLst/>
-          </a:prstGeom>
-          <a:noFill/>
-        </p:spPr>
-        <p:txBody>
-          <a:bodyPr wrap="square">
-            <a:spAutoFit/>
-          </a:bodyPr>
-          <a:lstStyle/>
-          <a:p>
-            <a:pPr algn="l"/>
-            <a:r>
-              <a:rPr sz="950" b="1" i="0">
+            <a:ext cx="1828800" cy="146304"/>
+          </a:xfrm>
+          <a:prstGeom prst="rect">
+            <a:avLst/>
+          </a:prstGeom>
+          <a:noFill/>
+        </p:spPr>
+        <p:txBody>
+          <a:bodyPr wrap="square">
+            <a:spAutoFit/>
+          </a:bodyPr>
+          <a:lstStyle/>
+          <a:p>
+            <a:pPr algn="l"/>
+            <a:r>
+              <a:rPr sz="900" b="1" i="0">
                 <a:solidFill>
                   <a:srgbClr val="0D2D5E"/>
                 </a:solidFill>
@@ -7634,29 +9429,28 @@
         </p:nvSpPr>
         <p:spPr>
           <a:xfrm>
-            <a:off x="7863840" y="5212079"/>
-            <a:ext cx="3840480" cy="329184"/>
-          </a:xfrm>
-          <a:prstGeom prst="rect">
-            <a:avLst/>
-          </a:prstGeom>
-          <a:noFill/>
-        </p:spPr>
-        <p:txBody>
-          <a:bodyPr wrap="square">
-            <a:spAutoFit/>
-          </a:bodyPr>
-          <a:lstStyle/>
-          <a:p>
-            <a:pPr algn="l"/>
-            <a:r>
-              <a:rPr sz="900" b="0" i="0">
+            <a:off x="7863840" y="5102352"/>
+            <a:ext cx="3840480" cy="201168"/>
+          </a:xfrm>
+          <a:prstGeom prst="rect">
+            <a:avLst/>
+          </a:prstGeom>
+          <a:noFill/>
+        </p:spPr>
+        <p:txBody>
+          <a:bodyPr wrap="square">
+            <a:spAutoFit/>
+          </a:bodyPr>
+          <a:lstStyle/>
+          <a:p>
+            <a:pPr algn="l"/>
+            <a:r>
+              <a:rPr sz="800" b="0" i="0">
                 <a:solidFill>
                   <a:srgbClr val="2D3A4B"/>
                 </a:solidFill>
               </a:rPr>
-              <a:t>Live cases with full conversation
-history; loan type + date filters</a:t>
+              <a:t>Live cases with full conversation history; loan type + date filters</a:t>
             </a:r>
           </a:p>
         </p:txBody>
@@ -7669,8 +9463,8 @@
         </p:nvSpPr>
         <p:spPr>
           <a:xfrm>
-            <a:off x="7772400" y="5641848"/>
-            <a:ext cx="4114800" cy="658368"/>
+            <a:off x="7772400" y="5330952"/>
+            <a:ext cx="4114800" cy="384048"/>
           </a:xfrm>
           <a:prstGeom prst="rect">
             <a:avLst/>
@@ -7712,23 +9506,23 @@
         </p:nvSpPr>
         <p:spPr>
           <a:xfrm>
-            <a:off x="7863840" y="5669280"/>
-            <a:ext cx="1828800" cy="274320"/>
-          </a:xfrm>
-          <a:prstGeom prst="rect">
-            <a:avLst/>
-          </a:prstGeom>
-          <a:noFill/>
-        </p:spPr>
-        <p:txBody>
-          <a:bodyPr wrap="square">
-            <a:spAutoFit/>
-          </a:bodyPr>
-          <a:lstStyle/>
-          <a:p>
-            <a:pPr algn="l"/>
-            <a:r>
-              <a:rPr sz="950" b="1" i="0">
+            <a:off x="7863840" y="5358384"/>
+            <a:ext cx="1828800" cy="146304"/>
+          </a:xfrm>
+          <a:prstGeom prst="rect">
+            <a:avLst/>
+          </a:prstGeom>
+          <a:noFill/>
+        </p:spPr>
+        <p:txBody>
+          <a:bodyPr wrap="square">
+            <a:spAutoFit/>
+          </a:bodyPr>
+          <a:lstStyle/>
+          <a:p>
+            <a:pPr algn="l"/>
+            <a:r>
+              <a:rPr sz="900" b="1" i="0">
                 <a:solidFill>
                   <a:srgbClr val="0D2D5E"/>
                 </a:solidFill>
@@ -7746,29 +9540,28 @@
         </p:nvSpPr>
         <p:spPr>
           <a:xfrm>
-            <a:off x="7863840" y="5943599"/>
-            <a:ext cx="3840480" cy="329184"/>
-          </a:xfrm>
-          <a:prstGeom prst="rect">
-            <a:avLst/>
-          </a:prstGeom>
-          <a:noFill/>
-        </p:spPr>
-        <p:txBody>
-          <a:bodyPr wrap="square">
-            <a:spAutoFit/>
-          </a:bodyPr>
-          <a:lstStyle/>
-          <a:p>
-            <a:pPr algn="l"/>
-            <a:r>
-              <a:rPr sz="900" b="0" i="0">
+            <a:off x="7863840" y="5522976"/>
+            <a:ext cx="3840480" cy="201168"/>
+          </a:xfrm>
+          <a:prstGeom prst="rect">
+            <a:avLst/>
+          </a:prstGeom>
+          <a:noFill/>
+        </p:spPr>
+        <p:txBody>
+          <a:bodyPr wrap="square">
+            <a:spAutoFit/>
+          </a:bodyPr>
+          <a:lstStyle/>
+          <a:p>
+            <a:pPr algn="l"/>
+            <a:r>
+              <a:rPr sz="800" b="0" i="0">
                 <a:solidFill>
                   <a:srgbClr val="2D3A4B"/>
                 </a:solidFill>
               </a:rPr>
-              <a:t>Mark resolved + add comment;
-timestamp logged to JSON store</a:t>
+              <a:t>Mark resolved + add comment; timestamp logged to JSON store</a:t>
             </a:r>
           </a:p>
         </p:txBody>
@@ -7781,8 +9574,8 @@
         </p:nvSpPr>
         <p:spPr>
           <a:xfrm>
-            <a:off x="7772400" y="6373368"/>
-            <a:ext cx="4114800" cy="658368"/>
+            <a:off x="7772400" y="5751576"/>
+            <a:ext cx="4114800" cy="384048"/>
           </a:xfrm>
           <a:prstGeom prst="rect">
             <a:avLst/>
@@ -7824,23 +9617,23 @@
         </p:nvSpPr>
         <p:spPr>
           <a:xfrm>
-            <a:off x="7863840" y="6400800"/>
-            <a:ext cx="1828800" cy="274320"/>
-          </a:xfrm>
-          <a:prstGeom prst="rect">
-            <a:avLst/>
-          </a:prstGeom>
-          <a:noFill/>
-        </p:spPr>
-        <p:txBody>
-          <a:bodyPr wrap="square">
-            <a:spAutoFit/>
-          </a:bodyPr>
-          <a:lstStyle/>
-          <a:p>
-            <a:pPr algn="l"/>
-            <a:r>
-              <a:rPr sz="950" b="1" i="0">
+            <a:off x="7863840" y="5779008"/>
+            <a:ext cx="1828800" cy="146304"/>
+          </a:xfrm>
+          <a:prstGeom prst="rect">
+            <a:avLst/>
+          </a:prstGeom>
+          <a:noFill/>
+        </p:spPr>
+        <p:txBody>
+          <a:bodyPr wrap="square">
+            <a:spAutoFit/>
+          </a:bodyPr>
+          <a:lstStyle/>
+          <a:p>
+            <a:pPr algn="l"/>
+            <a:r>
+              <a:rPr sz="900" b="1" i="0">
                 <a:solidFill>
                   <a:srgbClr val="0D2D5E"/>
                 </a:solidFill>
@@ -7858,29 +9651,28 @@
         </p:nvSpPr>
         <p:spPr>
           <a:xfrm>
-            <a:off x="7863840" y="6675119"/>
-            <a:ext cx="3840480" cy="329184"/>
-          </a:xfrm>
-          <a:prstGeom prst="rect">
-            <a:avLst/>
-          </a:prstGeom>
-          <a:noFill/>
-        </p:spPr>
-        <p:txBody>
-          <a:bodyPr wrap="square">
-            <a:spAutoFit/>
-          </a:bodyPr>
-          <a:lstStyle/>
-          <a:p>
-            <a:pPr algn="l"/>
-            <a:r>
-              <a:rPr sz="900" b="0" i="0">
+            <a:off x="7863840" y="5943600"/>
+            <a:ext cx="3840480" cy="201168"/>
+          </a:xfrm>
+          <a:prstGeom prst="rect">
+            <a:avLst/>
+          </a:prstGeom>
+          <a:noFill/>
+        </p:spPr>
+        <p:txBody>
+          <a:bodyPr wrap="square">
+            <a:spAutoFit/>
+          </a:bodyPr>
+          <a:lstStyle/>
+          <a:p>
+            <a:pPr algn="l"/>
+            <a:r>
+              <a:rPr sz="800" b="0" i="0">
                 <a:solidFill>
                   <a:srgbClr val="2D3A4B"/>
                 </a:solidFill>
               </a:rPr>
-              <a:t>Sessions · Pending · Resolved ·
-P95 latency (from interactions.log)</a:t>
+              <a:t>Sessions · Pending · Resolved · P95 latency (from interactions.log)</a:t>
             </a:r>
           </a:p>
         </p:txBody>
@@ -7893,8 +9685,8 @@
         </p:nvSpPr>
         <p:spPr>
           <a:xfrm>
-            <a:off x="7772400" y="7104888"/>
-            <a:ext cx="4114800" cy="658368"/>
+            <a:off x="7772400" y="6172200"/>
+            <a:ext cx="4114800" cy="384048"/>
           </a:xfrm>
           <a:prstGeom prst="rect">
             <a:avLst/>
@@ -7936,23 +9728,23 @@
         </p:nvSpPr>
         <p:spPr>
           <a:xfrm>
-            <a:off x="7863840" y="7132320"/>
-            <a:ext cx="1828800" cy="274320"/>
-          </a:xfrm>
-          <a:prstGeom prst="rect">
-            <a:avLst/>
-          </a:prstGeom>
-          <a:noFill/>
-        </p:spPr>
-        <p:txBody>
-          <a:bodyPr wrap="square">
-            <a:spAutoFit/>
-          </a:bodyPr>
-          <a:lstStyle/>
-          <a:p>
-            <a:pPr algn="l"/>
-            <a:r>
-              <a:rPr sz="950" b="1" i="0">
+            <a:off x="7863840" y="6199632"/>
+            <a:ext cx="1828800" cy="146304"/>
+          </a:xfrm>
+          <a:prstGeom prst="rect">
+            <a:avLst/>
+          </a:prstGeom>
+          <a:noFill/>
+        </p:spPr>
+        <p:txBody>
+          <a:bodyPr wrap="square">
+            <a:spAutoFit/>
+          </a:bodyPr>
+          <a:lstStyle/>
+          <a:p>
+            <a:pPr algn="l"/>
+            <a:r>
+              <a:rPr sz="900" b="1" i="0">
                 <a:solidFill>
                   <a:srgbClr val="0D2D5E"/>
                 </a:solidFill>
@@ -7970,29 +9762,28 @@
         </p:nvSpPr>
         <p:spPr>
           <a:xfrm>
-            <a:off x="7863840" y="7406640"/>
-            <a:ext cx="3840480" cy="329184"/>
-          </a:xfrm>
-          <a:prstGeom prst="rect">
-            <a:avLst/>
-          </a:prstGeom>
-          <a:noFill/>
-        </p:spPr>
-        <p:txBody>
-          <a:bodyPr wrap="square">
-            <a:spAutoFit/>
-          </a:bodyPr>
-          <a:lstStyle/>
-          <a:p>
-            <a:pPr algn="l"/>
-            <a:r>
-              <a:rPr sz="900" b="0" i="0">
+            <a:off x="7863840" y="6364224"/>
+            <a:ext cx="3840480" cy="201168"/>
+          </a:xfrm>
+          <a:prstGeom prst="rect">
+            <a:avLst/>
+          </a:prstGeom>
+          <a:noFill/>
+        </p:spPr>
+        <p:txBody>
+          <a:bodyPr wrap="square">
+            <a:spAutoFit/>
+          </a:bodyPr>
+          <a:lstStyle/>
+          <a:p>
+            <a:pPr algn="l"/>
+            <a:r>
+              <a:rPr sz="800" b="0" i="0">
                 <a:solidFill>
                   <a:srgbClr val="2D3A4B"/>
                 </a:solidFill>
               </a:rPr>
-              <a:t>Last 50 turns; PII-masked;
-latency per turn; block flag</a:t>
+              <a:t>Last 50 turns; PII-masked; latency per turn; block flag</a:t>
             </a:r>
           </a:p>
         </p:txBody>
@@ -9849,7 +11640,7 @@
         <p:spPr>
           <a:xfrm>
             <a:off x="320040" y="1389888"/>
-            <a:ext cx="3822191" cy="4206240"/>
+            <a:ext cx="3822191" cy="3584448"/>
           </a:xfrm>
           <a:prstGeom prst="rect">
             <a:avLst/>
@@ -10108,7 +11899,7 @@
         <p:spPr>
           <a:xfrm>
             <a:off x="411479" y="3730752"/>
-            <a:ext cx="3639312" cy="1536192"/>
+            <a:ext cx="3639312" cy="877824"/>
           </a:xfrm>
           <a:prstGeom prst="rect">
             <a:avLst/>
@@ -10145,7 +11936,7 @@
         </p:nvSpPr>
         <p:spPr>
           <a:xfrm>
-            <a:off x="411479" y="5266944"/>
+            <a:off x="411479" y="4681728"/>
             <a:ext cx="3639312" cy="256032"/>
           </a:xfrm>
           <a:prstGeom prst="rect">
@@ -10188,7 +11979,7 @@
         </p:nvSpPr>
         <p:spPr>
           <a:xfrm>
-            <a:off x="411479" y="5266944"/>
+            <a:off x="411479" y="4681728"/>
             <a:ext cx="3639312" cy="256032"/>
           </a:xfrm>
           <a:prstGeom prst="rect">
@@ -10223,7 +12014,7 @@
         <p:spPr>
           <a:xfrm>
             <a:off x="4270248" y="1389888"/>
-            <a:ext cx="3822191" cy="4206240"/>
+            <a:ext cx="3822191" cy="3584448"/>
           </a:xfrm>
           <a:prstGeom prst="rect">
             <a:avLst/>
@@ -10482,7 +12273,7 @@
         <p:spPr>
           <a:xfrm>
             <a:off x="4361688" y="3730752"/>
-            <a:ext cx="3639312" cy="1536192"/>
+            <a:ext cx="3639312" cy="877824"/>
           </a:xfrm>
           <a:prstGeom prst="rect">
             <a:avLst/>
@@ -10519,7 +12310,7 @@
         </p:nvSpPr>
         <p:spPr>
           <a:xfrm>
-            <a:off x="4361688" y="5266944"/>
+            <a:off x="4361688" y="4681728"/>
             <a:ext cx="3639312" cy="256032"/>
           </a:xfrm>
           <a:prstGeom prst="rect">
@@ -10562,7 +12353,7 @@
         </p:nvSpPr>
         <p:spPr>
           <a:xfrm>
-            <a:off x="4361688" y="5266944"/>
+            <a:off x="4361688" y="4681728"/>
             <a:ext cx="3639312" cy="256032"/>
           </a:xfrm>
           <a:prstGeom prst="rect">
@@ -10597,7 +12388,7 @@
         <p:spPr>
           <a:xfrm>
             <a:off x="8220456" y="1389888"/>
-            <a:ext cx="3822191" cy="4206240"/>
+            <a:ext cx="3822191" cy="3584448"/>
           </a:xfrm>
           <a:prstGeom prst="rect">
             <a:avLst/>
@@ -10856,7 +12647,7 @@
         <p:spPr>
           <a:xfrm>
             <a:off x="8311896" y="3730752"/>
-            <a:ext cx="3639312" cy="1536192"/>
+            <a:ext cx="3639312" cy="877824"/>
           </a:xfrm>
           <a:prstGeom prst="rect">
             <a:avLst/>
@@ -10893,7 +12684,7 @@
         </p:nvSpPr>
         <p:spPr>
           <a:xfrm>
-            <a:off x="8311896" y="5266944"/>
+            <a:off x="8311896" y="4681728"/>
             <a:ext cx="3639312" cy="256032"/>
           </a:xfrm>
           <a:prstGeom prst="rect">
@@ -10936,7 +12727,7 @@
         </p:nvSpPr>
         <p:spPr>
           <a:xfrm>
-            <a:off x="8311896" y="5266944"/>
+            <a:off x="8311896" y="4681728"/>
             <a:ext cx="3639312" cy="256032"/>
           </a:xfrm>
           <a:prstGeom prst="rect">
@@ -10970,7 +12761,7 @@
         </p:nvSpPr>
         <p:spPr>
           <a:xfrm>
-            <a:off x="320040" y="5961888"/>
+            <a:off x="320040" y="5065775"/>
             <a:ext cx="11548872" cy="256032"/>
           </a:xfrm>
           <a:prstGeom prst="rect">
@@ -11013,7 +12804,7 @@
         </p:nvSpPr>
         <p:spPr>
           <a:xfrm>
-            <a:off x="457200" y="5980175"/>
+            <a:off x="457200" y="5084064"/>
             <a:ext cx="10972800" cy="219456"/>
           </a:xfrm>
           <a:prstGeom prst="rect">
@@ -11047,8 +12838,8 @@
         </p:nvSpPr>
         <p:spPr>
           <a:xfrm>
-            <a:off x="320040" y="6254496"/>
-            <a:ext cx="3749039" cy="1298448"/>
+            <a:off x="320040" y="5358383"/>
+            <a:ext cx="3749039" cy="822960"/>
           </a:xfrm>
           <a:prstGeom prst="rect">
             <a:avLst/>
@@ -11092,8 +12883,8 @@
         </p:nvSpPr>
         <p:spPr>
           <a:xfrm>
-            <a:off x="411479" y="6309360"/>
-            <a:ext cx="3566160" cy="1170432"/>
+            <a:off x="411479" y="5413248"/>
+            <a:ext cx="3566160" cy="713232"/>
           </a:xfrm>
           <a:prstGeom prst="rect">
             <a:avLst/>
@@ -11126,8 +12917,8 @@
         </p:nvSpPr>
         <p:spPr>
           <a:xfrm>
-            <a:off x="4142232" y="6254496"/>
-            <a:ext cx="3749039" cy="1298448"/>
+            <a:off x="4142232" y="5358383"/>
+            <a:ext cx="3749039" cy="822960"/>
           </a:xfrm>
           <a:prstGeom prst="rect">
             <a:avLst/>
@@ -11171,8 +12962,8 @@
         </p:nvSpPr>
         <p:spPr>
           <a:xfrm>
-            <a:off x="4233672" y="6309360"/>
-            <a:ext cx="3566160" cy="1170432"/>
+            <a:off x="4233672" y="5413248"/>
+            <a:ext cx="3566160" cy="713232"/>
           </a:xfrm>
           <a:prstGeom prst="rect">
             <a:avLst/>
@@ -11205,8 +12996,8 @@
         </p:nvSpPr>
         <p:spPr>
           <a:xfrm>
-            <a:off x="7964424" y="6254496"/>
-            <a:ext cx="3749039" cy="1298448"/>
+            <a:off x="7964424" y="5358383"/>
+            <a:ext cx="3749039" cy="822960"/>
           </a:xfrm>
           <a:prstGeom prst="rect">
             <a:avLst/>
@@ -11250,8 +13041,8 @@
         </p:nvSpPr>
         <p:spPr>
           <a:xfrm>
-            <a:off x="8055864" y="6309360"/>
-            <a:ext cx="3566160" cy="1170432"/>
+            <a:off x="8055864" y="5413248"/>
+            <a:ext cx="3566160" cy="713232"/>
           </a:xfrm>
           <a:prstGeom prst="rect">
             <a:avLst/>
@@ -12350,7 +14141,7 @@
         <p:spPr>
           <a:xfrm>
             <a:off x="320040" y="2779776"/>
-            <a:ext cx="11548872" cy="676656"/>
+            <a:ext cx="11548872" cy="530352"/>
           </a:xfrm>
           <a:prstGeom prst="rect">
             <a:avLst/>
@@ -12393,7 +14184,7 @@
         <p:spPr>
           <a:xfrm>
             <a:off x="457200" y="2807208"/>
-            <a:ext cx="1737360" cy="603504"/>
+            <a:ext cx="1737360" cy="493776"/>
           </a:xfrm>
           <a:prstGeom prst="rect">
             <a:avLst/>
@@ -12427,7 +14218,7 @@
         <p:spPr>
           <a:xfrm>
             <a:off x="2286000" y="2807208"/>
-            <a:ext cx="822960" cy="603504"/>
+            <a:ext cx="822960" cy="493776"/>
           </a:xfrm>
           <a:prstGeom prst="rect">
             <a:avLst/>
@@ -12461,7 +14252,7 @@
         <p:spPr>
           <a:xfrm>
             <a:off x="3200400" y="2807208"/>
-            <a:ext cx="1097280" cy="603504"/>
+            <a:ext cx="1097280" cy="493776"/>
           </a:xfrm>
           <a:prstGeom prst="rect">
             <a:avLst/>
@@ -12495,7 +14286,7 @@
         <p:spPr>
           <a:xfrm>
             <a:off x="4389120" y="2807208"/>
-            <a:ext cx="3291840" cy="603504"/>
+            <a:ext cx="3291840" cy="493776"/>
           </a:xfrm>
           <a:prstGeom prst="rect">
             <a:avLst/>
@@ -12529,7 +14320,7 @@
         <p:spPr>
           <a:xfrm>
             <a:off x="7772400" y="2807208"/>
-            <a:ext cx="4023360" cy="603504"/>
+            <a:ext cx="4023360" cy="493776"/>
           </a:xfrm>
           <a:prstGeom prst="rect">
             <a:avLst/>
@@ -12562,8 +14353,8 @@
         </p:nvSpPr>
         <p:spPr>
           <a:xfrm>
-            <a:off x="320040" y="3493008"/>
-            <a:ext cx="11548872" cy="676656"/>
+            <a:off x="320040" y="3346704"/>
+            <a:ext cx="11548872" cy="530352"/>
           </a:xfrm>
           <a:prstGeom prst="rect">
             <a:avLst/>
@@ -12605,8 +14396,8 @@
         </p:nvSpPr>
         <p:spPr>
           <a:xfrm>
-            <a:off x="457200" y="3520440"/>
-            <a:ext cx="1737360" cy="603504"/>
+            <a:off x="457200" y="3374136"/>
+            <a:ext cx="1737360" cy="493776"/>
           </a:xfrm>
           <a:prstGeom prst="rect">
             <a:avLst/>
@@ -12639,8 +14430,8 @@
         </p:nvSpPr>
         <p:spPr>
           <a:xfrm>
-            <a:off x="2286000" y="3520440"/>
-            <a:ext cx="822960" cy="603504"/>
+            <a:off x="2286000" y="3374136"/>
+            <a:ext cx="822960" cy="493776"/>
           </a:xfrm>
           <a:prstGeom prst="rect">
             <a:avLst/>
@@ -12673,8 +14464,8 @@
         </p:nvSpPr>
         <p:spPr>
           <a:xfrm>
-            <a:off x="3200400" y="3520440"/>
-            <a:ext cx="1097280" cy="603504"/>
+            <a:off x="3200400" y="3374136"/>
+            <a:ext cx="1097280" cy="493776"/>
           </a:xfrm>
           <a:prstGeom prst="rect">
             <a:avLst/>
@@ -12707,8 +14498,8 @@
         </p:nvSpPr>
         <p:spPr>
           <a:xfrm>
-            <a:off x="4389120" y="3520440"/>
-            <a:ext cx="3291840" cy="603504"/>
+            <a:off x="4389120" y="3374136"/>
+            <a:ext cx="3291840" cy="493776"/>
           </a:xfrm>
           <a:prstGeom prst="rect">
             <a:avLst/>
@@ -12741,8 +14532,8 @@
         </p:nvSpPr>
         <p:spPr>
           <a:xfrm>
-            <a:off x="7772400" y="3520440"/>
-            <a:ext cx="4023360" cy="603504"/>
+            <a:off x="7772400" y="3374136"/>
+            <a:ext cx="4023360" cy="493776"/>
           </a:xfrm>
           <a:prstGeom prst="rect">
             <a:avLst/>
@@ -12775,8 +14566,8 @@
         </p:nvSpPr>
         <p:spPr>
           <a:xfrm>
-            <a:off x="320040" y="4206240"/>
-            <a:ext cx="11548872" cy="676656"/>
+            <a:off x="320040" y="3913632"/>
+            <a:ext cx="11548872" cy="530352"/>
           </a:xfrm>
           <a:prstGeom prst="rect">
             <a:avLst/>
@@ -12818,8 +14609,8 @@
         </p:nvSpPr>
         <p:spPr>
           <a:xfrm>
-            <a:off x="457200" y="4233672"/>
-            <a:ext cx="1737360" cy="603504"/>
+            <a:off x="457200" y="3941064"/>
+            <a:ext cx="1737360" cy="493776"/>
           </a:xfrm>
           <a:prstGeom prst="rect">
             <a:avLst/>
@@ -12852,8 +14643,8 @@
         </p:nvSpPr>
         <p:spPr>
           <a:xfrm>
-            <a:off x="2286000" y="4233672"/>
-            <a:ext cx="822960" cy="603504"/>
+            <a:off x="2286000" y="3941064"/>
+            <a:ext cx="822960" cy="493776"/>
           </a:xfrm>
           <a:prstGeom prst="rect">
             <a:avLst/>
@@ -12886,8 +14677,8 @@
         </p:nvSpPr>
         <p:spPr>
           <a:xfrm>
-            <a:off x="3200400" y="4233672"/>
-            <a:ext cx="1097280" cy="603504"/>
+            <a:off x="3200400" y="3941064"/>
+            <a:ext cx="1097280" cy="493776"/>
           </a:xfrm>
           <a:prstGeom prst="rect">
             <a:avLst/>
@@ -12920,8 +14711,8 @@
         </p:nvSpPr>
         <p:spPr>
           <a:xfrm>
-            <a:off x="4389120" y="4233672"/>
-            <a:ext cx="3291840" cy="603504"/>
+            <a:off x="4389120" y="3941064"/>
+            <a:ext cx="3291840" cy="493776"/>
           </a:xfrm>
           <a:prstGeom prst="rect">
             <a:avLst/>
@@ -12954,8 +14745,8 @@
         </p:nvSpPr>
         <p:spPr>
           <a:xfrm>
-            <a:off x="7772400" y="4233672"/>
-            <a:ext cx="4023360" cy="603504"/>
+            <a:off x="7772400" y="3941064"/>
+            <a:ext cx="4023360" cy="493776"/>
           </a:xfrm>
           <a:prstGeom prst="rect">
             <a:avLst/>
@@ -12988,7 +14779,7 @@
         </p:nvSpPr>
         <p:spPr>
           <a:xfrm>
-            <a:off x="320040" y="4919472"/>
+            <a:off x="320040" y="4590288"/>
             <a:ext cx="11548872" cy="256032"/>
           </a:xfrm>
           <a:prstGeom prst="rect">
@@ -13031,7 +14822,7 @@
         </p:nvSpPr>
         <p:spPr>
           <a:xfrm>
-            <a:off x="457200" y="4937760"/>
+            <a:off x="457200" y="4608576"/>
             <a:ext cx="10972800" cy="219456"/>
           </a:xfrm>
           <a:prstGeom prst="rect">
@@ -13065,7 +14856,7 @@
         </p:nvSpPr>
         <p:spPr>
           <a:xfrm>
-            <a:off x="320040" y="5175504"/>
+            <a:off x="320040" y="4846320"/>
             <a:ext cx="11548872" cy="256032"/>
           </a:xfrm>
           <a:prstGeom prst="rect">
@@ -13108,7 +14899,7 @@
         </p:nvSpPr>
         <p:spPr>
           <a:xfrm>
-            <a:off x="457200" y="5193792"/>
+            <a:off x="457200" y="4864608"/>
             <a:ext cx="1828800" cy="219456"/>
           </a:xfrm>
           <a:prstGeom prst="rect">
@@ -13142,7 +14933,7 @@
         </p:nvSpPr>
         <p:spPr>
           <a:xfrm>
-            <a:off x="4572000" y="5193792"/>
+            <a:off x="4572000" y="4864608"/>
             <a:ext cx="1828800" cy="219456"/>
           </a:xfrm>
           <a:prstGeom prst="rect">
@@ -13176,7 +14967,7 @@
         </p:nvSpPr>
         <p:spPr>
           <a:xfrm>
-            <a:off x="6217920" y="5193792"/>
+            <a:off x="6217920" y="4864608"/>
             <a:ext cx="1828800" cy="219456"/>
           </a:xfrm>
           <a:prstGeom prst="rect">
@@ -13210,7 +15001,7 @@
         </p:nvSpPr>
         <p:spPr>
           <a:xfrm>
-            <a:off x="7863840" y="5193792"/>
+            <a:off x="7863840" y="4864608"/>
             <a:ext cx="1828800" cy="219456"/>
           </a:xfrm>
           <a:prstGeom prst="rect">
@@ -13244,8 +15035,8 @@
         </p:nvSpPr>
         <p:spPr>
           <a:xfrm>
-            <a:off x="320040" y="5431536"/>
-            <a:ext cx="11548872" cy="493776"/>
+            <a:off x="320040" y="5102352"/>
+            <a:ext cx="11548872" cy="329184"/>
           </a:xfrm>
           <a:prstGeom prst="rect">
             <a:avLst/>
@@ -13287,8 +15078,8 @@
         </p:nvSpPr>
         <p:spPr>
           <a:xfrm>
-            <a:off x="457200" y="5458968"/>
-            <a:ext cx="4023360" cy="420624"/>
+            <a:off x="457200" y="5129783"/>
+            <a:ext cx="4023360" cy="274320"/>
           </a:xfrm>
           <a:prstGeom prst="rect">
             <a:avLst/>
@@ -13321,8 +15112,8 @@
         </p:nvSpPr>
         <p:spPr>
           <a:xfrm>
-            <a:off x="4572000" y="5458968"/>
-            <a:ext cx="1554480" cy="420624"/>
+            <a:off x="4572000" y="5129783"/>
+            <a:ext cx="1554480" cy="274320"/>
           </a:xfrm>
           <a:prstGeom prst="rect">
             <a:avLst/>
@@ -13355,8 +15146,8 @@
         </p:nvSpPr>
         <p:spPr>
           <a:xfrm>
-            <a:off x="6217920" y="5458968"/>
-            <a:ext cx="1554480" cy="420624"/>
+            <a:off x="6217920" y="5129783"/>
+            <a:ext cx="1554480" cy="274320"/>
           </a:xfrm>
           <a:prstGeom prst="rect">
             <a:avLst/>
@@ -13389,8 +15180,8 @@
         </p:nvSpPr>
         <p:spPr>
           <a:xfrm>
-            <a:off x="7863840" y="5458968"/>
-            <a:ext cx="3749039" cy="420624"/>
+            <a:off x="7863840" y="5129783"/>
+            <a:ext cx="3749039" cy="274320"/>
           </a:xfrm>
           <a:prstGeom prst="rect">
             <a:avLst/>
@@ -13423,8 +15214,8 @@
         </p:nvSpPr>
         <p:spPr>
           <a:xfrm>
-            <a:off x="320040" y="5961888"/>
-            <a:ext cx="11548872" cy="493776"/>
+            <a:off x="320040" y="5468112"/>
+            <a:ext cx="11548872" cy="329184"/>
           </a:xfrm>
           <a:prstGeom prst="rect">
             <a:avLst/>
@@ -13466,8 +15257,8 @@
         </p:nvSpPr>
         <p:spPr>
           <a:xfrm>
-            <a:off x="457200" y="5989320"/>
-            <a:ext cx="4023360" cy="420624"/>
+            <a:off x="457200" y="5495544"/>
+            <a:ext cx="4023360" cy="274320"/>
           </a:xfrm>
           <a:prstGeom prst="rect">
             <a:avLst/>
@@ -13500,8 +15291,8 @@
         </p:nvSpPr>
         <p:spPr>
           <a:xfrm>
-            <a:off x="4572000" y="5989320"/>
-            <a:ext cx="1554480" cy="420624"/>
+            <a:off x="4572000" y="5495544"/>
+            <a:ext cx="1554480" cy="274320"/>
           </a:xfrm>
           <a:prstGeom prst="rect">
             <a:avLst/>
@@ -13534,8 +15325,8 @@
         </p:nvSpPr>
         <p:spPr>
           <a:xfrm>
-            <a:off x="6217920" y="5989320"/>
-            <a:ext cx="1554480" cy="420624"/>
+            <a:off x="6217920" y="5495544"/>
+            <a:ext cx="1554480" cy="274320"/>
           </a:xfrm>
           <a:prstGeom prst="rect">
             <a:avLst/>
@@ -13568,8 +15359,8 @@
         </p:nvSpPr>
         <p:spPr>
           <a:xfrm>
-            <a:off x="7863840" y="5989320"/>
-            <a:ext cx="3749039" cy="420624"/>
+            <a:off x="7863840" y="5495544"/>
+            <a:ext cx="3749039" cy="274320"/>
           </a:xfrm>
           <a:prstGeom prst="rect">
             <a:avLst/>
@@ -13602,8 +15393,8 @@
         </p:nvSpPr>
         <p:spPr>
           <a:xfrm>
-            <a:off x="320040" y="6492240"/>
-            <a:ext cx="11548872" cy="493776"/>
+            <a:off x="320040" y="5833872"/>
+            <a:ext cx="11548872" cy="329184"/>
           </a:xfrm>
           <a:prstGeom prst="rect">
             <a:avLst/>
@@ -13645,8 +15436,8 @@
         </p:nvSpPr>
         <p:spPr>
           <a:xfrm>
-            <a:off x="457200" y="6519672"/>
-            <a:ext cx="4023360" cy="420624"/>
+            <a:off x="457200" y="5861303"/>
+            <a:ext cx="4023360" cy="274320"/>
           </a:xfrm>
           <a:prstGeom prst="rect">
             <a:avLst/>
@@ -13679,8 +15470,8 @@
         </p:nvSpPr>
         <p:spPr>
           <a:xfrm>
-            <a:off x="4572000" y="6519672"/>
-            <a:ext cx="1554480" cy="420624"/>
+            <a:off x="4572000" y="5861303"/>
+            <a:ext cx="1554480" cy="274320"/>
           </a:xfrm>
           <a:prstGeom prst="rect">
             <a:avLst/>
@@ -13713,8 +15504,8 @@
         </p:nvSpPr>
         <p:spPr>
           <a:xfrm>
-            <a:off x="6217920" y="6519672"/>
-            <a:ext cx="1554480" cy="420624"/>
+            <a:off x="6217920" y="5861303"/>
+            <a:ext cx="1554480" cy="274320"/>
           </a:xfrm>
           <a:prstGeom prst="rect">
             <a:avLst/>
@@ -13747,8 +15538,8 @@
         </p:nvSpPr>
         <p:spPr>
           <a:xfrm>
-            <a:off x="7863840" y="6519672"/>
-            <a:ext cx="3749039" cy="420624"/>
+            <a:off x="7863840" y="5861303"/>
+            <a:ext cx="3749039" cy="274320"/>
           </a:xfrm>
           <a:prstGeom prst="rect">
             <a:avLst/>
@@ -13781,8 +15572,8 @@
         </p:nvSpPr>
         <p:spPr>
           <a:xfrm>
-            <a:off x="320040" y="7022592"/>
-            <a:ext cx="11548872" cy="493776"/>
+            <a:off x="320040" y="6199632"/>
+            <a:ext cx="11548872" cy="329184"/>
           </a:xfrm>
           <a:prstGeom prst="rect">
             <a:avLst/>
@@ -13824,8 +15615,8 @@
         </p:nvSpPr>
         <p:spPr>
           <a:xfrm>
-            <a:off x="457200" y="7050024"/>
-            <a:ext cx="4023360" cy="420624"/>
+            <a:off x="457200" y="6227064"/>
+            <a:ext cx="4023360" cy="274320"/>
           </a:xfrm>
           <a:prstGeom prst="rect">
             <a:avLst/>
@@ -13858,8 +15649,8 @@
         </p:nvSpPr>
         <p:spPr>
           <a:xfrm>
-            <a:off x="4572000" y="7050024"/>
-            <a:ext cx="1554480" cy="420624"/>
+            <a:off x="4572000" y="6227064"/>
+            <a:ext cx="1554480" cy="274320"/>
           </a:xfrm>
           <a:prstGeom prst="rect">
             <a:avLst/>
@@ -13892,8 +15683,8 @@
         </p:nvSpPr>
         <p:spPr>
           <a:xfrm>
-            <a:off x="6217920" y="7050024"/>
-            <a:ext cx="1554480" cy="420624"/>
+            <a:off x="6217920" y="6227064"/>
+            <a:ext cx="1554480" cy="274320"/>
           </a:xfrm>
           <a:prstGeom prst="rect">
             <a:avLst/>
@@ -13926,8 +15717,8 @@
         </p:nvSpPr>
         <p:spPr>
           <a:xfrm>
-            <a:off x="7863840" y="7050024"/>
-            <a:ext cx="3749039" cy="420624"/>
+            <a:off x="7863840" y="6227064"/>
+            <a:ext cx="3749039" cy="274320"/>
           </a:xfrm>
           <a:prstGeom prst="rect">
             <a:avLst/>
@@ -13954,77 +15745,34 @@
       </p:sp>
       <p:sp>
         <p:nvSpPr>
-          <p:cNvPr id="75" name="Rectangle 74"/>
-          <p:cNvSpPr/>
-          <p:nvPr/>
-        </p:nvSpPr>
-        <p:spPr>
-          <a:xfrm>
-            <a:off x="320040" y="7552944"/>
-            <a:ext cx="11548872" cy="256032"/>
-          </a:xfrm>
-          <a:prstGeom prst="rect">
-            <a:avLst/>
-          </a:prstGeom>
-          <a:solidFill>
-            <a:srgbClr val="D97B06"/>
-          </a:solidFill>
-          <a:ln>
-            <a:noFill/>
-          </a:ln>
-        </p:spPr>
-        <p:style>
-          <a:lnRef idx="1">
-            <a:schemeClr val="accent1"/>
-          </a:lnRef>
-          <a:fillRef idx="3">
-            <a:schemeClr val="accent1"/>
-          </a:fillRef>
-          <a:effectRef idx="2">
-            <a:schemeClr val="accent1"/>
-          </a:effectRef>
-          <a:fontRef idx="minor">
-            <a:schemeClr val="lt1"/>
-          </a:fontRef>
-        </p:style>
-        <p:txBody>
-          <a:bodyPr rtlCol="0" anchor="ctr"/>
-          <a:lstStyle/>
-          <a:p>
-            <a:pPr algn="ctr"/>
-          </a:p>
-        </p:txBody>
-      </p:sp>
-      <p:sp>
-        <p:nvSpPr>
-          <p:cNvPr id="76" name="TextBox 75"/>
-          <p:cNvSpPr txBox="1"/>
-          <p:nvPr/>
-        </p:nvSpPr>
-        <p:spPr>
-          <a:xfrm>
-            <a:off x="457200" y="7571231"/>
-            <a:ext cx="11155680" cy="219456"/>
-          </a:xfrm>
-          <a:prstGeom prst="rect">
-            <a:avLst/>
-          </a:prstGeom>
-          <a:noFill/>
-        </p:spPr>
-        <p:txBody>
-          <a:bodyPr wrap="square">
-            <a:spAutoFit/>
-          </a:bodyPr>
-          <a:lstStyle/>
-          <a:p>
-            <a:pPr algn="l"/>
-            <a:r>
-              <a:rPr sz="900" b="1" i="0">
-                <a:solidFill>
-                  <a:srgbClr val="FFFFFF"/>
-                </a:solidFill>
-              </a:rPr>
-              <a:t>ROOT-CAUSE FIX:  chunk without product-label prefix → wrong-product retrieval → score 0.4  ⟶  add [MSME LOAN] prefix → correct retrieval → score 1.0</a:t>
+          <p:cNvPr id="75" name="TextBox 74"/>
+          <p:cNvSpPr txBox="1"/>
+          <p:nvPr/>
+        </p:nvSpPr>
+        <p:spPr>
+          <a:xfrm>
+            <a:off x="320040" y="6537960"/>
+            <a:ext cx="11521440" cy="256032"/>
+          </a:xfrm>
+          <a:prstGeom prst="rect">
+            <a:avLst/>
+          </a:prstGeom>
+          <a:noFill/>
+        </p:spPr>
+        <p:txBody>
+          <a:bodyPr wrap="square">
+            <a:spAutoFit/>
+          </a:bodyPr>
+          <a:lstStyle/>
+          <a:p>
+            <a:pPr algn="l"/>
+            <a:r>
+              <a:rPr sz="750" b="0" i="1">
+                <a:solidFill>
+                  <a:srgbClr val="6B7C93"/>
+                </a:solidFill>
+              </a:rPr>
+              <a:t>Root-cause fix: chunk without product-label prefix → wrong-product retrieval → score 0.4  ⟶  add [MSME LOAN] prefix → score 1.0.  Run: python scripts/run_evaluation.py --suite all</a:t>
             </a:r>
           </a:p>
         </p:txBody>
@@ -16727,7 +18475,7 @@
         <p:spPr>
           <a:xfrm>
             <a:off x="320040" y="5888736"/>
-            <a:ext cx="5669280" cy="585216"/>
+            <a:ext cx="5669280" cy="420624"/>
           </a:xfrm>
           <a:prstGeom prst="rect">
             <a:avLst/>
@@ -16770,7 +18518,7 @@
         <p:spPr>
           <a:xfrm>
             <a:off x="457200" y="5916168"/>
-            <a:ext cx="1920240" cy="256032"/>
+            <a:ext cx="1920240" cy="182880"/>
           </a:xfrm>
           <a:prstGeom prst="rect">
             <a:avLst/>
@@ -16804,7 +18552,7 @@
         <p:spPr>
           <a:xfrm>
             <a:off x="2377440" y="5916168"/>
-            <a:ext cx="3566160" cy="512064"/>
+            <a:ext cx="3566160" cy="365760"/>
           </a:xfrm>
           <a:prstGeom prst="rect">
             <a:avLst/>
@@ -16838,7 +18586,7 @@
         <p:spPr>
           <a:xfrm>
             <a:off x="6126479" y="5888736"/>
-            <a:ext cx="5669280" cy="585216"/>
+            <a:ext cx="5669280" cy="420624"/>
           </a:xfrm>
           <a:prstGeom prst="rect">
             <a:avLst/>
@@ -16881,7 +18629,7 @@
         <p:spPr>
           <a:xfrm>
             <a:off x="6263640" y="5916168"/>
-            <a:ext cx="1920240" cy="256032"/>
+            <a:ext cx="1920240" cy="182880"/>
           </a:xfrm>
           <a:prstGeom prst="rect">
             <a:avLst/>
@@ -16915,7 +18663,7 @@
         <p:spPr>
           <a:xfrm>
             <a:off x="8183879" y="5916168"/>
-            <a:ext cx="3566160" cy="512064"/>
+            <a:ext cx="3566160" cy="365760"/>
           </a:xfrm>
           <a:prstGeom prst="rect">
             <a:avLst/>
@@ -16948,8 +18696,8 @@
         </p:nvSpPr>
         <p:spPr>
           <a:xfrm>
-            <a:off x="320040" y="6547103"/>
-            <a:ext cx="5669280" cy="585216"/>
+            <a:off x="320040" y="6345936"/>
+            <a:ext cx="5669280" cy="420624"/>
           </a:xfrm>
           <a:prstGeom prst="rect">
             <a:avLst/>
@@ -16991,8 +18739,8 @@
         </p:nvSpPr>
         <p:spPr>
           <a:xfrm>
-            <a:off x="457200" y="6574536"/>
-            <a:ext cx="1920240" cy="256032"/>
+            <a:off x="457200" y="6373368"/>
+            <a:ext cx="1920240" cy="182880"/>
           </a:xfrm>
           <a:prstGeom prst="rect">
             <a:avLst/>
@@ -17025,8 +18773,8 @@
         </p:nvSpPr>
         <p:spPr>
           <a:xfrm>
-            <a:off x="2377440" y="6574536"/>
-            <a:ext cx="3566160" cy="512064"/>
+            <a:off x="2377440" y="6373368"/>
+            <a:ext cx="3566160" cy="365760"/>
           </a:xfrm>
           <a:prstGeom prst="rect">
             <a:avLst/>
@@ -17059,8 +18807,8 @@
         </p:nvSpPr>
         <p:spPr>
           <a:xfrm>
-            <a:off x="6126479" y="6547103"/>
-            <a:ext cx="5669280" cy="585216"/>
+            <a:off x="6126479" y="6345936"/>
+            <a:ext cx="5669280" cy="420624"/>
           </a:xfrm>
           <a:prstGeom prst="rect">
             <a:avLst/>
@@ -17102,8 +18850,8 @@
         </p:nvSpPr>
         <p:spPr>
           <a:xfrm>
-            <a:off x="6263640" y="6574536"/>
-            <a:ext cx="1920240" cy="256032"/>
+            <a:off x="6263640" y="6373368"/>
+            <a:ext cx="1920240" cy="182880"/>
           </a:xfrm>
           <a:prstGeom prst="rect">
             <a:avLst/>
@@ -17136,8 +18884,8 @@
         </p:nvSpPr>
         <p:spPr>
           <a:xfrm>
-            <a:off x="8183879" y="6574536"/>
-            <a:ext cx="3566160" cy="512064"/>
+            <a:off x="8183879" y="6373368"/>
+            <a:ext cx="3566160" cy="365760"/>
           </a:xfrm>
           <a:prstGeom prst="rect">
             <a:avLst/>
@@ -31735,7 +33483,7 @@
         <p:spPr>
           <a:xfrm>
             <a:off x="320040" y="4791456"/>
-            <a:ext cx="5623560" cy="2487168"/>
+            <a:ext cx="5623560" cy="1664208"/>
           </a:xfrm>
           <a:prstGeom prst="rect">
             <a:avLst/>
@@ -31814,7 +33562,7 @@
         <p:spPr>
           <a:xfrm>
             <a:off x="429768" y="5120640"/>
-            <a:ext cx="5376672" cy="2029968"/>
+            <a:ext cx="5376672" cy="1188720"/>
           </a:xfrm>
           <a:prstGeom prst="rect">
             <a:avLst/>
@@ -31848,7 +33596,7 @@
         <p:spPr>
           <a:xfrm>
             <a:off x="6080760" y="4791456"/>
-            <a:ext cx="5623560" cy="2487168"/>
+            <a:ext cx="5623560" cy="1664208"/>
           </a:xfrm>
           <a:prstGeom prst="rect">
             <a:avLst/>
@@ -31927,7 +33675,7 @@
         <p:spPr>
           <a:xfrm>
             <a:off x="6190488" y="5120640"/>
-            <a:ext cx="5376672" cy="2029968"/>
+            <a:ext cx="5376672" cy="1188720"/>
           </a:xfrm>
           <a:prstGeom prst="rect">
             <a:avLst/>
@@ -34289,4 +36037,324 @@
   </a:objectDefaults>
   <a:extraClrSchemeLst/>
 </a:theme>
+</file>
+
+<file path=ppt/theme/theme2.xml><?xml version="1.0" encoding="utf-8"?>
+<a:theme xmlns:a="http://schemas.openxmlformats.org/drawingml/2006/main" name="Office Theme">
+  <a:themeElements>
+    <a:clrScheme name="Office">
+      <a:dk1>
+        <a:sysClr val="windowText" lastClr="000000"/>
+      </a:dk1>
+      <a:lt1>
+        <a:sysClr val="window" lastClr="FFFFFF"/>
+      </a:lt1>
+      <a:dk2>
+        <a:srgbClr val="1F497D"/>
+      </a:dk2>
+      <a:lt2>
+        <a:srgbClr val="EEECE1"/>
+      </a:lt2>
+      <a:accent1>
+        <a:srgbClr val="4F81BD"/>
+      </a:accent1>
+      <a:accent2>
+        <a:srgbClr val="C0504D"/>
+      </a:accent2>
+      <a:accent3>
+        <a:srgbClr val="9BBB59"/>
+      </a:accent3>
+      <a:accent4>
+        <a:srgbClr val="8064A2"/>
+      </a:accent4>
+      <a:accent5>
+        <a:srgbClr val="4BACC6"/>
+      </a:accent5>
+      <a:accent6>
+        <a:srgbClr val="F79646"/>
+      </a:accent6>
+      <a:hlink>
+        <a:srgbClr val="0000FF"/>
+      </a:hlink>
+      <a:folHlink>
+        <a:srgbClr val="800080"/>
+      </a:folHlink>
+    </a:clrScheme>
+    <a:fontScheme name="Office">
+      <a:majorFont>
+        <a:latin typeface="Calibri"/>
+        <a:ea typeface=""/>
+        <a:cs typeface=""/>
+        <a:font script="Jpan" typeface="ＭＳ Ｐゴシック"/>
+        <a:font script="Hang" typeface="맑은 고딕"/>
+        <a:font script="Hans" typeface="宋体"/>
+        <a:font script="Hant" typeface="新細明體"/>
+        <a:font script="Arab" typeface="Times New Roman"/>
+        <a:font script="Hebr" typeface="Times New Roman"/>
+        <a:font script="Thai" typeface="Angsana New"/>
+        <a:font script="Ethi" typeface="Nyala"/>
+        <a:font script="Beng" typeface="Vrinda"/>
+        <a:font script="Gujr" typeface="Shruti"/>
+        <a:font script="Khmr" typeface="MoolBoran"/>
+        <a:font script="Knda" typeface="Tunga"/>
+        <a:font script="Guru" typeface="Raavi"/>
+        <a:font script="Cans" typeface="Euphemia"/>
+        <a:font script="Cher" typeface="Plantagenet Cherokee"/>
+        <a:font script="Yiii" typeface="Microsoft Yi Baiti"/>
+        <a:font script="Tibt" typeface="Microsoft Himalaya"/>
+        <a:font script="Thaa" typeface="MV Boli"/>
+        <a:font script="Deva" typeface="Mangal"/>
+        <a:font script="Telu" typeface="Gautami"/>
+        <a:font script="Taml" typeface="Latha"/>
+        <a:font script="Syrc" typeface="Estrangelo Edessa"/>
+        <a:font script="Orya" typeface="Kalinga"/>
+        <a:font script="Mlym" typeface="Kartika"/>
+        <a:font script="Laoo" typeface="DokChampa"/>
+        <a:font script="Sinh" typeface="Iskoola Pota"/>
+        <a:font script="Mong" typeface="Mongolian Baiti"/>
+        <a:font script="Viet" typeface="Times New Roman"/>
+        <a:font script="Uigh" typeface="Microsoft Uighur"/>
+        <a:font script="Geor" typeface="Sylfaen"/>
+      </a:majorFont>
+      <a:minorFont>
+        <a:latin typeface="Calibri"/>
+        <a:ea typeface=""/>
+        <a:cs typeface=""/>
+        <a:font script="Jpan" typeface="ＭＳ Ｐゴシック"/>
+        <a:font script="Hang" typeface="맑은 고딕"/>
+        <a:font script="Hans" typeface="宋体"/>
+        <a:font script="Hant" typeface="新細明體"/>
+        <a:font script="Arab" typeface="Arial"/>
+        <a:font script="Hebr" typeface="Arial"/>
+        <a:font script="Thai" typeface="Cordia New"/>
+        <a:font script="Ethi" typeface="Nyala"/>
+        <a:font script="Beng" typeface="Vrinda"/>
+        <a:font script="Gujr" typeface="Shruti"/>
+        <a:font script="Khmr" typeface="DaunPenh"/>
+        <a:font script="Knda" typeface="Tunga"/>
+        <a:font script="Guru" typeface="Raavi"/>
+        <a:font script="Cans" typeface="Euphemia"/>
+        <a:font script="Cher" typeface="Plantagenet Cherokee"/>
+        <a:font script="Yiii" typeface="Microsoft Yi Baiti"/>
+        <a:font script="Tibt" typeface="Microsoft Himalaya"/>
+        <a:font script="Thaa" typeface="MV Boli"/>
+        <a:font script="Deva" typeface="Mangal"/>
+        <a:font script="Telu" typeface="Gautami"/>
+        <a:font script="Taml" typeface="Latha"/>
+        <a:font script="Syrc" typeface="Estrangelo Edessa"/>
+        <a:font script="Orya" typeface="Kalinga"/>
+        <a:font script="Mlym" typeface="Kartika"/>
+        <a:font script="Laoo" typeface="DokChampa"/>
+        <a:font script="Sinh" typeface="Iskoola Pota"/>
+        <a:font script="Mong" typeface="Mongolian Baiti"/>
+        <a:font script="Viet" typeface="Arial"/>
+        <a:font script="Uigh" typeface="Microsoft Uighur"/>
+        <a:font script="Geor" typeface="Sylfaen"/>
+      </a:minorFont>
+    </a:fontScheme>
+    <a:fmtScheme name="Office">
+      <a:fillStyleLst>
+        <a:solidFill>
+          <a:schemeClr val="phClr"/>
+        </a:solidFill>
+        <a:gradFill rotWithShape="1">
+          <a:gsLst>
+            <a:gs pos="0">
+              <a:schemeClr val="phClr">
+                <a:tint val="50000"/>
+                <a:satMod val="300000"/>
+              </a:schemeClr>
+            </a:gs>
+            <a:gs pos="35000">
+              <a:schemeClr val="phClr">
+                <a:tint val="37000"/>
+                <a:satMod val="300000"/>
+              </a:schemeClr>
+            </a:gs>
+            <a:gs pos="100000">
+              <a:schemeClr val="phClr">
+                <a:tint val="15000"/>
+                <a:satMod val="350000"/>
+              </a:schemeClr>
+            </a:gs>
+          </a:gsLst>
+          <a:lin ang="16200000" scaled="1"/>
+        </a:gradFill>
+        <a:gradFill rotWithShape="1">
+          <a:gsLst>
+            <a:gs pos="0">
+              <a:schemeClr val="phClr">
+                <a:tint val="100000"/>
+                <a:shade val="100000"/>
+                <a:satMod val="130000"/>
+              </a:schemeClr>
+            </a:gs>
+            <a:gs pos="100000">
+              <a:schemeClr val="phClr">
+                <a:tint val="50000"/>
+                <a:shade val="100000"/>
+                <a:satMod val="350000"/>
+              </a:schemeClr>
+            </a:gs>
+          </a:gsLst>
+          <a:lin ang="16200000" scaled="0"/>
+        </a:gradFill>
+      </a:fillStyleLst>
+      <a:lnStyleLst>
+        <a:ln w="9525" cap="flat" cmpd="sng" algn="ctr">
+          <a:solidFill>
+            <a:schemeClr val="phClr">
+              <a:shade val="95000"/>
+              <a:satMod val="105000"/>
+            </a:schemeClr>
+          </a:solidFill>
+          <a:prstDash val="solid"/>
+        </a:ln>
+        <a:ln w="25400" cap="flat" cmpd="sng" algn="ctr">
+          <a:solidFill>
+            <a:schemeClr val="phClr"/>
+          </a:solidFill>
+          <a:prstDash val="solid"/>
+        </a:ln>
+        <a:ln w="38100" cap="flat" cmpd="sng" algn="ctr">
+          <a:solidFill>
+            <a:schemeClr val="phClr"/>
+          </a:solidFill>
+          <a:prstDash val="solid"/>
+        </a:ln>
+      </a:lnStyleLst>
+      <a:effectStyleLst>
+        <a:effectStyle>
+          <a:effectLst>
+            <a:outerShdw blurRad="40000" dist="20000" dir="5400000" rotWithShape="0">
+              <a:srgbClr val="000000">
+                <a:alpha val="38000"/>
+              </a:srgbClr>
+            </a:outerShdw>
+          </a:effectLst>
+        </a:effectStyle>
+        <a:effectStyle>
+          <a:effectLst>
+            <a:outerShdw blurRad="40000" dist="23000" dir="5400000" rotWithShape="0">
+              <a:srgbClr val="000000">
+                <a:alpha val="35000"/>
+              </a:srgbClr>
+            </a:outerShdw>
+          </a:effectLst>
+        </a:effectStyle>
+        <a:effectStyle>
+          <a:effectLst>
+            <a:outerShdw blurRad="40000" dist="23000" dir="5400000" rotWithShape="0">
+              <a:srgbClr val="000000">
+                <a:alpha val="35000"/>
+              </a:srgbClr>
+            </a:outerShdw>
+          </a:effectLst>
+          <a:scene3d>
+            <a:camera prst="orthographicFront">
+              <a:rot lat="0" lon="0" rev="0"/>
+            </a:camera>
+            <a:lightRig rig="threePt" dir="t">
+              <a:rot lat="0" lon="0" rev="1200000"/>
+            </a:lightRig>
+          </a:scene3d>
+          <a:sp3d>
+            <a:bevelT w="63500" h="25400"/>
+          </a:sp3d>
+        </a:effectStyle>
+      </a:effectStyleLst>
+      <a:bgFillStyleLst>
+        <a:solidFill>
+          <a:schemeClr val="phClr"/>
+        </a:solidFill>
+        <a:gradFill rotWithShape="1">
+          <a:gsLst>
+            <a:gs pos="0">
+              <a:schemeClr val="phClr">
+                <a:tint val="40000"/>
+                <a:satMod val="350000"/>
+              </a:schemeClr>
+            </a:gs>
+            <a:gs pos="40000">
+              <a:schemeClr val="phClr">
+                <a:tint val="45000"/>
+                <a:shade val="99000"/>
+                <a:satMod val="350000"/>
+              </a:schemeClr>
+            </a:gs>
+            <a:gs pos="100000">
+              <a:schemeClr val="phClr">
+                <a:shade val="20000"/>
+                <a:satMod val="255000"/>
+              </a:schemeClr>
+            </a:gs>
+          </a:gsLst>
+          <a:path path="circle">
+            <a:fillToRect l="50000" t="-80000" r="50000" b="180000"/>
+          </a:path>
+        </a:gradFill>
+        <a:gradFill rotWithShape="1">
+          <a:gsLst>
+            <a:gs pos="0">
+              <a:schemeClr val="phClr">
+                <a:tint val="80000"/>
+                <a:satMod val="300000"/>
+              </a:schemeClr>
+            </a:gs>
+            <a:gs pos="100000">
+              <a:schemeClr val="phClr">
+                <a:shade val="30000"/>
+                <a:satMod val="200000"/>
+              </a:schemeClr>
+            </a:gs>
+          </a:gsLst>
+          <a:path path="circle">
+            <a:fillToRect l="50000" t="50000" r="50000" b="50000"/>
+          </a:path>
+        </a:gradFill>
+      </a:bgFillStyleLst>
+    </a:fmtScheme>
+  </a:themeElements>
+  <a:objectDefaults>
+    <a:spDef>
+      <a:spPr/>
+      <a:bodyPr/>
+      <a:lstStyle/>
+      <a:style>
+        <a:lnRef idx="1">
+          <a:schemeClr val="accent1"/>
+        </a:lnRef>
+        <a:fillRef idx="3">
+          <a:schemeClr val="accent1"/>
+        </a:fillRef>
+        <a:effectRef idx="2">
+          <a:schemeClr val="accent1"/>
+        </a:effectRef>
+        <a:fontRef idx="minor">
+          <a:schemeClr val="lt1"/>
+        </a:fontRef>
+      </a:style>
+    </a:spDef>
+    <a:lnDef>
+      <a:spPr/>
+      <a:bodyPr/>
+      <a:lstStyle/>
+      <a:style>
+        <a:lnRef idx="2">
+          <a:schemeClr val="accent1"/>
+        </a:lnRef>
+        <a:fillRef idx="0">
+          <a:schemeClr val="accent1"/>
+        </a:fillRef>
+        <a:effectRef idx="1">
+          <a:schemeClr val="accent1"/>
+        </a:effectRef>
+        <a:fontRef idx="minor">
+          <a:schemeClr val="tx1"/>
+        </a:fontRef>
+      </a:style>
+    </a:lnDef>
+  </a:objectDefaults>
+  <a:extraClrSchemeLst/>
+</a:theme>
 </file>
</xml_diff>

<commit_message>
fix: S6 rubric table — replace 0.35" stub labels with dedicated 0.88" navy label column
Row label stubs at x=0.38 w=0.35 were inside the P2 phase column and got
overwritten by phase data (size-6 text invisible behind data cells).

Fix: introduce a dedicated 0.88" navy label column (RUBRIC DIMENSION /
KEY METRIC / EVIDENCE / KEY ARTIFACT in white bold text); shift the 8 phase
data columns right by LBL_W so they start at x=1.23. Rubric content unchanged.

Co-Authored-By: Claude Sonnet 4.6 <noreply@anthropic.com>
</commit_message>
<xml_diff>
--- a/docs/capstone_presentation.pptx
+++ b/docs/capstone_presentation.pptx
@@ -29178,41 +29178,85 @@
       </p:sp>
       <p:sp>
         <p:nvSpPr>
-          <p:cNvPr id="67" name="TextBox 66"/>
+          <p:cNvPr id="67" name="Rectangle 66"/>
+          <p:cNvSpPr/>
+          <p:nvPr/>
+        </p:nvSpPr>
+        <p:spPr>
+          <a:xfrm>
+            <a:off x="320040" y="4315968"/>
+            <a:ext cx="804672" cy="475488"/>
+          </a:xfrm>
+          <a:prstGeom prst="rect">
+            <a:avLst/>
+          </a:prstGeom>
+          <a:solidFill>
+            <a:srgbClr val="0D2D5E"/>
+          </a:solidFill>
+          <a:ln>
+            <a:noFill/>
+          </a:ln>
+        </p:spPr>
+        <p:style>
+          <a:lnRef idx="1">
+            <a:schemeClr val="accent1"/>
+          </a:lnRef>
+          <a:fillRef idx="3">
+            <a:schemeClr val="accent1"/>
+          </a:fillRef>
+          <a:effectRef idx="2">
+            <a:schemeClr val="accent1"/>
+          </a:effectRef>
+          <a:fontRef idx="minor">
+            <a:schemeClr val="lt1"/>
+          </a:fontRef>
+        </p:style>
+        <p:txBody>
+          <a:bodyPr rtlCol="0" anchor="ctr"/>
+          <a:lstStyle/>
+          <a:p>
+            <a:pPr algn="ctr"/>
+          </a:p>
+        </p:txBody>
+      </p:sp>
+      <p:sp>
+        <p:nvSpPr>
+          <p:cNvPr id="68" name="TextBox 67"/>
           <p:cNvSpPr txBox="1"/>
           <p:nvPr/>
         </p:nvSpPr>
         <p:spPr>
           <a:xfrm>
             <a:off x="347472" y="4352544"/>
-            <a:ext cx="320040" cy="420624"/>
-          </a:xfrm>
-          <a:prstGeom prst="rect">
-            <a:avLst/>
-          </a:prstGeom>
-          <a:noFill/>
-        </p:spPr>
-        <p:txBody>
-          <a:bodyPr wrap="square">
-            <a:spAutoFit/>
-          </a:bodyPr>
-          <a:lstStyle/>
-          <a:p>
-            <a:pPr algn="l"/>
-            <a:r>
-              <a:rPr sz="600" b="1" i="0">
-                <a:solidFill>
-                  <a:srgbClr val="6B7C93"/>
-                </a:solidFill>
-              </a:rPr>
-              <a:t>RUBRIC DIMENSION</a:t>
-            </a:r>
-          </a:p>
-        </p:txBody>
-      </p:sp>
-      <p:sp>
-        <p:nvSpPr>
-          <p:cNvPr id="68" name="Rectangle 67"/>
+            <a:ext cx="749808" cy="402336"/>
+          </a:xfrm>
+          <a:prstGeom prst="rect">
+            <a:avLst/>
+          </a:prstGeom>
+          <a:noFill/>
+        </p:spPr>
+        <p:txBody>
+          <a:bodyPr wrap="square">
+            <a:spAutoFit/>
+          </a:bodyPr>
+          <a:lstStyle/>
+          <a:p>
+            <a:pPr algn="ctr"/>
+            <a:r>
+              <a:rPr sz="700" b="1" i="0">
+                <a:solidFill>
+                  <a:srgbClr val="FFFFFF"/>
+                </a:solidFill>
+              </a:rPr>
+              <a:t>RUBRIC
+DIMENSION</a:t>
+            </a:r>
+          </a:p>
+        </p:txBody>
+      </p:sp>
+      <p:sp>
+        <p:nvSpPr>
+          <p:cNvPr id="69" name="Rectangle 68"/>
           <p:cNvSpPr/>
           <p:nvPr/>
         </p:nvSpPr>
@@ -29255,41 +29299,85 @@
       </p:sp>
       <p:sp>
         <p:nvSpPr>
-          <p:cNvPr id="69" name="TextBox 68"/>
+          <p:cNvPr id="70" name="Rectangle 69"/>
+          <p:cNvSpPr/>
+          <p:nvPr/>
+        </p:nvSpPr>
+        <p:spPr>
+          <a:xfrm>
+            <a:off x="320040" y="4791456"/>
+            <a:ext cx="804672" cy="530352"/>
+          </a:xfrm>
+          <a:prstGeom prst="rect">
+            <a:avLst/>
+          </a:prstGeom>
+          <a:solidFill>
+            <a:srgbClr val="0D2D5E"/>
+          </a:solidFill>
+          <a:ln>
+            <a:noFill/>
+          </a:ln>
+        </p:spPr>
+        <p:style>
+          <a:lnRef idx="1">
+            <a:schemeClr val="accent1"/>
+          </a:lnRef>
+          <a:fillRef idx="3">
+            <a:schemeClr val="accent1"/>
+          </a:fillRef>
+          <a:effectRef idx="2">
+            <a:schemeClr val="accent1"/>
+          </a:effectRef>
+          <a:fontRef idx="minor">
+            <a:schemeClr val="lt1"/>
+          </a:fontRef>
+        </p:style>
+        <p:txBody>
+          <a:bodyPr rtlCol="0" anchor="ctr"/>
+          <a:lstStyle/>
+          <a:p>
+            <a:pPr algn="ctr"/>
+          </a:p>
+        </p:txBody>
+      </p:sp>
+      <p:sp>
+        <p:nvSpPr>
+          <p:cNvPr id="71" name="TextBox 70"/>
           <p:cNvSpPr txBox="1"/>
           <p:nvPr/>
         </p:nvSpPr>
         <p:spPr>
           <a:xfrm>
             <a:off x="347472" y="4828032"/>
-            <a:ext cx="320040" cy="475488"/>
-          </a:xfrm>
-          <a:prstGeom prst="rect">
-            <a:avLst/>
-          </a:prstGeom>
-          <a:noFill/>
-        </p:spPr>
-        <p:txBody>
-          <a:bodyPr wrap="square">
-            <a:spAutoFit/>
-          </a:bodyPr>
-          <a:lstStyle/>
-          <a:p>
-            <a:pPr algn="l"/>
-            <a:r>
-              <a:rPr sz="600" b="1" i="0">
-                <a:solidFill>
-                  <a:srgbClr val="6B7C93"/>
-                </a:solidFill>
-              </a:rPr>
-              <a:t>KEY METRIC / EVIDENCE</a:t>
-            </a:r>
-          </a:p>
-        </p:txBody>
-      </p:sp>
-      <p:sp>
-        <p:nvSpPr>
-          <p:cNvPr id="70" name="Rectangle 69"/>
+            <a:ext cx="749808" cy="457199"/>
+          </a:xfrm>
+          <a:prstGeom prst="rect">
+            <a:avLst/>
+          </a:prstGeom>
+          <a:noFill/>
+        </p:spPr>
+        <p:txBody>
+          <a:bodyPr wrap="square">
+            <a:spAutoFit/>
+          </a:bodyPr>
+          <a:lstStyle/>
+          <a:p>
+            <a:pPr algn="ctr"/>
+            <a:r>
+              <a:rPr sz="700" b="1" i="0">
+                <a:solidFill>
+                  <a:srgbClr val="FFFFFF"/>
+                </a:solidFill>
+              </a:rPr>
+              <a:t>KEY METRIC /
+EVIDENCE</a:t>
+            </a:r>
+          </a:p>
+        </p:txBody>
+      </p:sp>
+      <p:sp>
+        <p:nvSpPr>
+          <p:cNvPr id="72" name="Rectangle 71"/>
           <p:cNvSpPr/>
           <p:nvPr/>
         </p:nvSpPr>
@@ -29332,48 +29420,92 @@
       </p:sp>
       <p:sp>
         <p:nvSpPr>
-          <p:cNvPr id="71" name="TextBox 70"/>
+          <p:cNvPr id="73" name="Rectangle 72"/>
+          <p:cNvSpPr/>
+          <p:nvPr/>
+        </p:nvSpPr>
+        <p:spPr>
+          <a:xfrm>
+            <a:off x="320040" y="5321808"/>
+            <a:ext cx="804672" cy="475488"/>
+          </a:xfrm>
+          <a:prstGeom prst="rect">
+            <a:avLst/>
+          </a:prstGeom>
+          <a:solidFill>
+            <a:srgbClr val="0D2D5E"/>
+          </a:solidFill>
+          <a:ln>
+            <a:noFill/>
+          </a:ln>
+        </p:spPr>
+        <p:style>
+          <a:lnRef idx="1">
+            <a:schemeClr val="accent1"/>
+          </a:lnRef>
+          <a:fillRef idx="3">
+            <a:schemeClr val="accent1"/>
+          </a:fillRef>
+          <a:effectRef idx="2">
+            <a:schemeClr val="accent1"/>
+          </a:effectRef>
+          <a:fontRef idx="minor">
+            <a:schemeClr val="lt1"/>
+          </a:fontRef>
+        </p:style>
+        <p:txBody>
+          <a:bodyPr rtlCol="0" anchor="ctr"/>
+          <a:lstStyle/>
+          <a:p>
+            <a:pPr algn="ctr"/>
+          </a:p>
+        </p:txBody>
+      </p:sp>
+      <p:sp>
+        <p:nvSpPr>
+          <p:cNvPr id="74" name="TextBox 73"/>
           <p:cNvSpPr txBox="1"/>
           <p:nvPr/>
         </p:nvSpPr>
         <p:spPr>
           <a:xfrm>
             <a:off x="347472" y="5358384"/>
-            <a:ext cx="320040" cy="420624"/>
-          </a:xfrm>
-          <a:prstGeom prst="rect">
-            <a:avLst/>
-          </a:prstGeom>
-          <a:noFill/>
-        </p:spPr>
-        <p:txBody>
-          <a:bodyPr wrap="square">
-            <a:spAutoFit/>
-          </a:bodyPr>
-          <a:lstStyle/>
-          <a:p>
-            <a:pPr algn="l"/>
-            <a:r>
-              <a:rPr sz="600" b="1" i="0">
-                <a:solidFill>
-                  <a:srgbClr val="6B7C93"/>
-                </a:solidFill>
-              </a:rPr>
-              <a:t>KEY ARTIFACT</a:t>
-            </a:r>
-          </a:p>
-        </p:txBody>
-      </p:sp>
-      <p:sp>
-        <p:nvSpPr>
-          <p:cNvPr id="72" name="TextBox 71"/>
-          <p:cNvSpPr txBox="1"/>
-          <p:nvPr/>
-        </p:nvSpPr>
-        <p:spPr>
-          <a:xfrm>
-            <a:off x="356615" y="4352544"/>
-            <a:ext cx="1388745" cy="420624"/>
+            <a:ext cx="749808" cy="402336"/>
+          </a:xfrm>
+          <a:prstGeom prst="rect">
+            <a:avLst/>
+          </a:prstGeom>
+          <a:noFill/>
+        </p:spPr>
+        <p:txBody>
+          <a:bodyPr wrap="square">
+            <a:spAutoFit/>
+          </a:bodyPr>
+          <a:lstStyle/>
+          <a:p>
+            <a:pPr algn="ctr"/>
+            <a:r>
+              <a:rPr sz="700" b="1" i="0">
+                <a:solidFill>
+                  <a:srgbClr val="FFFFFF"/>
+                </a:solidFill>
+              </a:rPr>
+              <a:t>KEY
+ARTIFACT</a:t>
+            </a:r>
+          </a:p>
+        </p:txBody>
+      </p:sp>
+      <p:sp>
+        <p:nvSpPr>
+          <p:cNvPr id="75" name="TextBox 74"/>
+          <p:cNvSpPr txBox="1"/>
+          <p:nvPr/>
+        </p:nvSpPr>
+        <p:spPr>
+          <a:xfrm>
+            <a:off x="1161288" y="4352544"/>
+            <a:ext cx="1288161" cy="420624"/>
           </a:xfrm>
           <a:prstGeom prst="rect">
             <a:avLst/>
@@ -29401,14 +29533,14 @@
       </p:sp>
       <p:sp>
         <p:nvSpPr>
-          <p:cNvPr id="73" name="TextBox 72"/>
-          <p:cNvSpPr txBox="1"/>
-          <p:nvPr/>
-        </p:nvSpPr>
-        <p:spPr>
-          <a:xfrm>
-            <a:off x="356615" y="4828032"/>
-            <a:ext cx="1388745" cy="475488"/>
+          <p:cNvPr id="76" name="TextBox 75"/>
+          <p:cNvSpPr txBox="1"/>
+          <p:nvPr/>
+        </p:nvSpPr>
+        <p:spPr>
+          <a:xfrm>
+            <a:off x="1161288" y="4828032"/>
+            <a:ext cx="1288161" cy="475488"/>
           </a:xfrm>
           <a:prstGeom prst="rect">
             <a:avLst/>
@@ -29436,14 +29568,14 @@
       </p:sp>
       <p:sp>
         <p:nvSpPr>
-          <p:cNvPr id="74" name="TextBox 73"/>
-          <p:cNvSpPr txBox="1"/>
-          <p:nvPr/>
-        </p:nvSpPr>
-        <p:spPr>
-          <a:xfrm>
-            <a:off x="356615" y="5358384"/>
-            <a:ext cx="1388745" cy="420624"/>
+          <p:cNvPr id="77" name="TextBox 76"/>
+          <p:cNvSpPr txBox="1"/>
+          <p:nvPr/>
+        </p:nvSpPr>
+        <p:spPr>
+          <a:xfrm>
+            <a:off x="1161288" y="5358384"/>
+            <a:ext cx="1288161" cy="420624"/>
           </a:xfrm>
           <a:prstGeom prst="rect">
             <a:avLst/>
@@ -29471,14 +29603,14 @@
       </p:sp>
       <p:sp>
         <p:nvSpPr>
-          <p:cNvPr id="75" name="TextBox 74"/>
-          <p:cNvSpPr txBox="1"/>
-          <p:nvPr/>
-        </p:nvSpPr>
-        <p:spPr>
-          <a:xfrm>
-            <a:off x="1800225" y="4352544"/>
-            <a:ext cx="1388745" cy="420624"/>
+          <p:cNvPr id="78" name="TextBox 77"/>
+          <p:cNvSpPr txBox="1"/>
+          <p:nvPr/>
+        </p:nvSpPr>
+        <p:spPr>
+          <a:xfrm>
+            <a:off x="2504313" y="4352544"/>
+            <a:ext cx="1288161" cy="420624"/>
           </a:xfrm>
           <a:prstGeom prst="rect">
             <a:avLst/>
@@ -29506,14 +29638,14 @@
       </p:sp>
       <p:sp>
         <p:nvSpPr>
-          <p:cNvPr id="76" name="TextBox 75"/>
-          <p:cNvSpPr txBox="1"/>
-          <p:nvPr/>
-        </p:nvSpPr>
-        <p:spPr>
-          <a:xfrm>
-            <a:off x="1800225" y="4828032"/>
-            <a:ext cx="1388745" cy="475488"/>
+          <p:cNvPr id="79" name="TextBox 78"/>
+          <p:cNvSpPr txBox="1"/>
+          <p:nvPr/>
+        </p:nvSpPr>
+        <p:spPr>
+          <a:xfrm>
+            <a:off x="2504313" y="4828032"/>
+            <a:ext cx="1288161" cy="475488"/>
           </a:xfrm>
           <a:prstGeom prst="rect">
             <a:avLst/>
@@ -29541,14 +29673,14 @@
       </p:sp>
       <p:sp>
         <p:nvSpPr>
-          <p:cNvPr id="77" name="TextBox 76"/>
-          <p:cNvSpPr txBox="1"/>
-          <p:nvPr/>
-        </p:nvSpPr>
-        <p:spPr>
-          <a:xfrm>
-            <a:off x="1800225" y="5358384"/>
-            <a:ext cx="1388745" cy="420624"/>
+          <p:cNvPr id="80" name="TextBox 79"/>
+          <p:cNvSpPr txBox="1"/>
+          <p:nvPr/>
+        </p:nvSpPr>
+        <p:spPr>
+          <a:xfrm>
+            <a:off x="2504313" y="5358384"/>
+            <a:ext cx="1288161" cy="420624"/>
           </a:xfrm>
           <a:prstGeom prst="rect">
             <a:avLst/>
@@ -29576,14 +29708,14 @@
       </p:sp>
       <p:sp>
         <p:nvSpPr>
-          <p:cNvPr id="78" name="TextBox 77"/>
-          <p:cNvSpPr txBox="1"/>
-          <p:nvPr/>
-        </p:nvSpPr>
-        <p:spPr>
-          <a:xfrm>
-            <a:off x="3243834" y="4352544"/>
-            <a:ext cx="1388745" cy="420624"/>
+          <p:cNvPr id="81" name="TextBox 80"/>
+          <p:cNvSpPr txBox="1"/>
+          <p:nvPr/>
+        </p:nvSpPr>
+        <p:spPr>
+          <a:xfrm>
+            <a:off x="3847338" y="4352544"/>
+            <a:ext cx="1288161" cy="420624"/>
           </a:xfrm>
           <a:prstGeom prst="rect">
             <a:avLst/>
@@ -29611,14 +29743,14 @@
       </p:sp>
       <p:sp>
         <p:nvSpPr>
-          <p:cNvPr id="79" name="TextBox 78"/>
-          <p:cNvSpPr txBox="1"/>
-          <p:nvPr/>
-        </p:nvSpPr>
-        <p:spPr>
-          <a:xfrm>
-            <a:off x="3243834" y="4828032"/>
-            <a:ext cx="1388745" cy="475488"/>
+          <p:cNvPr id="82" name="TextBox 81"/>
+          <p:cNvSpPr txBox="1"/>
+          <p:nvPr/>
+        </p:nvSpPr>
+        <p:spPr>
+          <a:xfrm>
+            <a:off x="3847338" y="4828032"/>
+            <a:ext cx="1288161" cy="475488"/>
           </a:xfrm>
           <a:prstGeom prst="rect">
             <a:avLst/>
@@ -29646,14 +29778,14 @@
       </p:sp>
       <p:sp>
         <p:nvSpPr>
-          <p:cNvPr id="80" name="TextBox 79"/>
-          <p:cNvSpPr txBox="1"/>
-          <p:nvPr/>
-        </p:nvSpPr>
-        <p:spPr>
-          <a:xfrm>
-            <a:off x="3243834" y="5358384"/>
-            <a:ext cx="1388745" cy="420624"/>
+          <p:cNvPr id="83" name="TextBox 82"/>
+          <p:cNvSpPr txBox="1"/>
+          <p:nvPr/>
+        </p:nvSpPr>
+        <p:spPr>
+          <a:xfrm>
+            <a:off x="3847338" y="5358384"/>
+            <a:ext cx="1288161" cy="420624"/>
           </a:xfrm>
           <a:prstGeom prst="rect">
             <a:avLst/>
@@ -29681,14 +29813,14 @@
       </p:sp>
       <p:sp>
         <p:nvSpPr>
-          <p:cNvPr id="81" name="TextBox 80"/>
-          <p:cNvSpPr txBox="1"/>
-          <p:nvPr/>
-        </p:nvSpPr>
-        <p:spPr>
-          <a:xfrm>
-            <a:off x="4687443" y="4352544"/>
-            <a:ext cx="1388745" cy="420624"/>
+          <p:cNvPr id="84" name="TextBox 83"/>
+          <p:cNvSpPr txBox="1"/>
+          <p:nvPr/>
+        </p:nvSpPr>
+        <p:spPr>
+          <a:xfrm>
+            <a:off x="5190363" y="4352544"/>
+            <a:ext cx="1288161" cy="420624"/>
           </a:xfrm>
           <a:prstGeom prst="rect">
             <a:avLst/>
@@ -29716,14 +29848,14 @@
       </p:sp>
       <p:sp>
         <p:nvSpPr>
-          <p:cNvPr id="82" name="TextBox 81"/>
-          <p:cNvSpPr txBox="1"/>
-          <p:nvPr/>
-        </p:nvSpPr>
-        <p:spPr>
-          <a:xfrm>
-            <a:off x="4687443" y="4828032"/>
-            <a:ext cx="1388745" cy="475488"/>
+          <p:cNvPr id="85" name="TextBox 84"/>
+          <p:cNvSpPr txBox="1"/>
+          <p:nvPr/>
+        </p:nvSpPr>
+        <p:spPr>
+          <a:xfrm>
+            <a:off x="5190363" y="4828032"/>
+            <a:ext cx="1288161" cy="475488"/>
           </a:xfrm>
           <a:prstGeom prst="rect">
             <a:avLst/>
@@ -29751,14 +29883,14 @@
       </p:sp>
       <p:sp>
         <p:nvSpPr>
-          <p:cNvPr id="83" name="TextBox 82"/>
-          <p:cNvSpPr txBox="1"/>
-          <p:nvPr/>
-        </p:nvSpPr>
-        <p:spPr>
-          <a:xfrm>
-            <a:off x="4687443" y="5358384"/>
-            <a:ext cx="1388745" cy="420624"/>
+          <p:cNvPr id="86" name="TextBox 85"/>
+          <p:cNvSpPr txBox="1"/>
+          <p:nvPr/>
+        </p:nvSpPr>
+        <p:spPr>
+          <a:xfrm>
+            <a:off x="5190363" y="5358384"/>
+            <a:ext cx="1288161" cy="420624"/>
           </a:xfrm>
           <a:prstGeom prst="rect">
             <a:avLst/>
@@ -29786,14 +29918,14 @@
       </p:sp>
       <p:sp>
         <p:nvSpPr>
-          <p:cNvPr id="84" name="TextBox 83"/>
-          <p:cNvSpPr txBox="1"/>
-          <p:nvPr/>
-        </p:nvSpPr>
-        <p:spPr>
-          <a:xfrm>
-            <a:off x="6131052" y="4352544"/>
-            <a:ext cx="1388745" cy="420624"/>
+          <p:cNvPr id="87" name="TextBox 86"/>
+          <p:cNvSpPr txBox="1"/>
+          <p:nvPr/>
+        </p:nvSpPr>
+        <p:spPr>
+          <a:xfrm>
+            <a:off x="6533388" y="4352544"/>
+            <a:ext cx="1288161" cy="420624"/>
           </a:xfrm>
           <a:prstGeom prst="rect">
             <a:avLst/>
@@ -29821,14 +29953,14 @@
       </p:sp>
       <p:sp>
         <p:nvSpPr>
-          <p:cNvPr id="85" name="TextBox 84"/>
-          <p:cNvSpPr txBox="1"/>
-          <p:nvPr/>
-        </p:nvSpPr>
-        <p:spPr>
-          <a:xfrm>
-            <a:off x="6131052" y="4828032"/>
-            <a:ext cx="1388745" cy="475488"/>
+          <p:cNvPr id="88" name="TextBox 87"/>
+          <p:cNvSpPr txBox="1"/>
+          <p:nvPr/>
+        </p:nvSpPr>
+        <p:spPr>
+          <a:xfrm>
+            <a:off x="6533388" y="4828032"/>
+            <a:ext cx="1288161" cy="475488"/>
           </a:xfrm>
           <a:prstGeom prst="rect">
             <a:avLst/>
@@ -29856,14 +29988,14 @@
       </p:sp>
       <p:sp>
         <p:nvSpPr>
-          <p:cNvPr id="86" name="TextBox 85"/>
-          <p:cNvSpPr txBox="1"/>
-          <p:nvPr/>
-        </p:nvSpPr>
-        <p:spPr>
-          <a:xfrm>
-            <a:off x="6131052" y="5358384"/>
-            <a:ext cx="1388745" cy="420624"/>
+          <p:cNvPr id="89" name="TextBox 88"/>
+          <p:cNvSpPr txBox="1"/>
+          <p:nvPr/>
+        </p:nvSpPr>
+        <p:spPr>
+          <a:xfrm>
+            <a:off x="6533388" y="5358384"/>
+            <a:ext cx="1288161" cy="420624"/>
           </a:xfrm>
           <a:prstGeom prst="rect">
             <a:avLst/>
@@ -29891,14 +30023,14 @@
       </p:sp>
       <p:sp>
         <p:nvSpPr>
-          <p:cNvPr id="87" name="TextBox 86"/>
-          <p:cNvSpPr txBox="1"/>
-          <p:nvPr/>
-        </p:nvSpPr>
-        <p:spPr>
-          <a:xfrm>
-            <a:off x="7574661" y="4352544"/>
-            <a:ext cx="1388745" cy="420624"/>
+          <p:cNvPr id="90" name="TextBox 89"/>
+          <p:cNvSpPr txBox="1"/>
+          <p:nvPr/>
+        </p:nvSpPr>
+        <p:spPr>
+          <a:xfrm>
+            <a:off x="7876413" y="4352544"/>
+            <a:ext cx="1288161" cy="420624"/>
           </a:xfrm>
           <a:prstGeom prst="rect">
             <a:avLst/>
@@ -29926,14 +30058,14 @@
       </p:sp>
       <p:sp>
         <p:nvSpPr>
-          <p:cNvPr id="88" name="TextBox 87"/>
-          <p:cNvSpPr txBox="1"/>
-          <p:nvPr/>
-        </p:nvSpPr>
-        <p:spPr>
-          <a:xfrm>
-            <a:off x="7574661" y="4828032"/>
-            <a:ext cx="1388745" cy="475488"/>
+          <p:cNvPr id="91" name="TextBox 90"/>
+          <p:cNvSpPr txBox="1"/>
+          <p:nvPr/>
+        </p:nvSpPr>
+        <p:spPr>
+          <a:xfrm>
+            <a:off x="7876413" y="4828032"/>
+            <a:ext cx="1288161" cy="475488"/>
           </a:xfrm>
           <a:prstGeom prst="rect">
             <a:avLst/>
@@ -29961,14 +30093,14 @@
       </p:sp>
       <p:sp>
         <p:nvSpPr>
-          <p:cNvPr id="89" name="TextBox 88"/>
-          <p:cNvSpPr txBox="1"/>
-          <p:nvPr/>
-        </p:nvSpPr>
-        <p:spPr>
-          <a:xfrm>
-            <a:off x="7574661" y="5358384"/>
-            <a:ext cx="1388745" cy="420624"/>
+          <p:cNvPr id="92" name="TextBox 91"/>
+          <p:cNvSpPr txBox="1"/>
+          <p:nvPr/>
+        </p:nvSpPr>
+        <p:spPr>
+          <a:xfrm>
+            <a:off x="7876413" y="5358384"/>
+            <a:ext cx="1288161" cy="420624"/>
           </a:xfrm>
           <a:prstGeom prst="rect">
             <a:avLst/>
@@ -29996,14 +30128,14 @@
       </p:sp>
       <p:sp>
         <p:nvSpPr>
-          <p:cNvPr id="90" name="TextBox 89"/>
-          <p:cNvSpPr txBox="1"/>
-          <p:nvPr/>
-        </p:nvSpPr>
-        <p:spPr>
-          <a:xfrm>
-            <a:off x="9018269" y="4352544"/>
-            <a:ext cx="1388745" cy="420624"/>
+          <p:cNvPr id="93" name="TextBox 92"/>
+          <p:cNvSpPr txBox="1"/>
+          <p:nvPr/>
+        </p:nvSpPr>
+        <p:spPr>
+          <a:xfrm>
+            <a:off x="9219438" y="4352544"/>
+            <a:ext cx="1288161" cy="420624"/>
           </a:xfrm>
           <a:prstGeom prst="rect">
             <a:avLst/>
@@ -30031,14 +30163,14 @@
       </p:sp>
       <p:sp>
         <p:nvSpPr>
-          <p:cNvPr id="91" name="TextBox 90"/>
-          <p:cNvSpPr txBox="1"/>
-          <p:nvPr/>
-        </p:nvSpPr>
-        <p:spPr>
-          <a:xfrm>
-            <a:off x="9018269" y="4828032"/>
-            <a:ext cx="1388745" cy="475488"/>
+          <p:cNvPr id="94" name="TextBox 93"/>
+          <p:cNvSpPr txBox="1"/>
+          <p:nvPr/>
+        </p:nvSpPr>
+        <p:spPr>
+          <a:xfrm>
+            <a:off x="9219438" y="4828032"/>
+            <a:ext cx="1288161" cy="475488"/>
           </a:xfrm>
           <a:prstGeom prst="rect">
             <a:avLst/>
@@ -30066,14 +30198,14 @@
       </p:sp>
       <p:sp>
         <p:nvSpPr>
-          <p:cNvPr id="92" name="TextBox 91"/>
-          <p:cNvSpPr txBox="1"/>
-          <p:nvPr/>
-        </p:nvSpPr>
-        <p:spPr>
-          <a:xfrm>
-            <a:off x="9018269" y="5358384"/>
-            <a:ext cx="1388745" cy="420624"/>
+          <p:cNvPr id="95" name="TextBox 94"/>
+          <p:cNvSpPr txBox="1"/>
+          <p:nvPr/>
+        </p:nvSpPr>
+        <p:spPr>
+          <a:xfrm>
+            <a:off x="9219438" y="5358384"/>
+            <a:ext cx="1288161" cy="420624"/>
           </a:xfrm>
           <a:prstGeom prst="rect">
             <a:avLst/>
@@ -30101,14 +30233,14 @@
       </p:sp>
       <p:sp>
         <p:nvSpPr>
-          <p:cNvPr id="93" name="TextBox 92"/>
-          <p:cNvSpPr txBox="1"/>
-          <p:nvPr/>
-        </p:nvSpPr>
-        <p:spPr>
-          <a:xfrm>
-            <a:off x="10461879" y="4352544"/>
-            <a:ext cx="1388745" cy="420624"/>
+          <p:cNvPr id="96" name="TextBox 95"/>
+          <p:cNvSpPr txBox="1"/>
+          <p:nvPr/>
+        </p:nvSpPr>
+        <p:spPr>
+          <a:xfrm>
+            <a:off x="10562463" y="4352544"/>
+            <a:ext cx="1288161" cy="420624"/>
           </a:xfrm>
           <a:prstGeom prst="rect">
             <a:avLst/>
@@ -30136,14 +30268,14 @@
       </p:sp>
       <p:sp>
         <p:nvSpPr>
-          <p:cNvPr id="94" name="TextBox 93"/>
-          <p:cNvSpPr txBox="1"/>
-          <p:nvPr/>
-        </p:nvSpPr>
-        <p:spPr>
-          <a:xfrm>
-            <a:off x="10461879" y="4828032"/>
-            <a:ext cx="1388745" cy="475488"/>
+          <p:cNvPr id="97" name="TextBox 96"/>
+          <p:cNvSpPr txBox="1"/>
+          <p:nvPr/>
+        </p:nvSpPr>
+        <p:spPr>
+          <a:xfrm>
+            <a:off x="10562463" y="4828032"/>
+            <a:ext cx="1288161" cy="475488"/>
           </a:xfrm>
           <a:prstGeom prst="rect">
             <a:avLst/>
@@ -30171,14 +30303,14 @@
       </p:sp>
       <p:sp>
         <p:nvSpPr>
-          <p:cNvPr id="95" name="TextBox 94"/>
-          <p:cNvSpPr txBox="1"/>
-          <p:nvPr/>
-        </p:nvSpPr>
-        <p:spPr>
-          <a:xfrm>
-            <a:off x="10461879" y="5358384"/>
-            <a:ext cx="1388745" cy="420624"/>
+          <p:cNvPr id="98" name="TextBox 97"/>
+          <p:cNvSpPr txBox="1"/>
+          <p:nvPr/>
+        </p:nvSpPr>
+        <p:spPr>
+          <a:xfrm>
+            <a:off x="10562463" y="5358384"/>
+            <a:ext cx="1288161" cy="420624"/>
           </a:xfrm>
           <a:prstGeom prst="rect">
             <a:avLst/>
@@ -30206,7 +30338,7 @@
       </p:sp>
       <p:sp>
         <p:nvSpPr>
-          <p:cNvPr id="96" name="TextBox 95"/>
+          <p:cNvPr id="99" name="TextBox 98"/>
           <p:cNvSpPr txBox="1"/>
           <p:nvPr/>
         </p:nvSpPr>

</xml_diff>

<commit_message>
refactor: rename lookup_loan_status → query_loan_policy across all files
The old name implied checking an existing loan application's processing
status (a core banking capability). The tool actually does RAG-backed
policy FAQ lookup (rates, tenure, charges, NRI rules, CIBIL criteria).

Renamed in: tools/tool_search.py (function + docstring), tool_registry.py,
agent/prompts.py, CLAUDE.md, IMPLEMENTATION_PLAN.md, README.md,
docs/evaluation_report.md, docs/presentation_script.md, skills/SKILL.md,
scripts/build_presentation.py (+ PPTX rebuild), notebooks/phase5_tools.ipynb.

Pending (docx skill required): docs/specification_v2.docx, docs/concept_document.docx

233 tests still passing.

Co-Authored-By: Claude Sonnet 4.6 <noreply@anthropic.com>
</commit_message>
<xml_diff>
--- a/docs/capstone_presentation.pptx
+++ b/docs/capstone_presentation.pptx
@@ -31930,7 +31930,7 @@
                   <a:srgbClr val="0D2D5E"/>
                 </a:solidFill>
               </a:rPr>
-              <a:t>lookup_loan_status</a:t>
+              <a:t>query_loan_policy</a:t>
             </a:r>
           </a:p>
         </p:txBody>
@@ -33521,7 +33521,7 @@
                 </a:solidFill>
               </a:rPr>
               <a:t>RAG_TOP_K = 5
-lookup_loan_status
+query_loan_policy
 tool calls this
 MMR diversity
 re-ranking</a:t>

</xml_diff>

<commit_message>
fix(presentation): update test count 244 → 426 in all 6 slides
Co-Authored-By: Claude Sonnet 4.6 <noreply@anthropic.com>
</commit_message>
<xml_diff>
--- a/docs/capstone_presentation.pptx
+++ b/docs/capstone_presentation.pptx
@@ -532,7 +532,7 @@
           </a:p>
           <a:p>
             <a:r>
-              <a:t>Built in 10 days across 8 phases; 244 tests passing. Let me walk you through the architecture and key decisions.</a:t>
+              <a:t>Built in 10 days across 8 phases; 426 tests passing. Let me walk you through the architecture and key decisions.</a:t>
             </a:r>
           </a:p>
         </p:txBody>
@@ -982,7 +982,7 @@
           </a:p>
           <a:p>
             <a:r>
-              <a:t>244 automated tests provide regression coverage; scripts/run_evaluation.py --suite all runs all 3 evaluation suites.</a:t>
+              <a:t>426 automated tests provide regression coverage; scripts/run_evaluation.py --suite all runs all 3 evaluation suites.</a:t>
             </a:r>
           </a:p>
         </p:txBody>
@@ -1627,7 +1627,7 @@
           </a:p>
           <a:p>
             <a:r>
-              <a:t>All 8 phases are complete — verified by 244 passing tests and 8 Jupyter demo notebooks.</a:t>
+              <a:t>All 8 phases are complete — verified by 426 passing tests and 8 Jupyter demo notebooks.</a:t>
             </a:r>
           </a:p>
           <a:p>
@@ -5712,7 +5712,7 @@
                   <a:srgbClr val="D4AF37"/>
                 </a:solidFill>
               </a:rPr>
-              <a:t>244</a:t>
+              <a:t>426</a:t>
             </a:r>
           </a:p>
         </p:txBody>
@@ -13894,7 +13894,7 @@
                   <a:srgbClr val="D4AF37"/>
                 </a:solidFill>
               </a:rPr>
-              <a:t>244</a:t>
+              <a:t>426</a:t>
             </a:r>
           </a:p>
         </p:txBody>
@@ -19801,7 +19801,7 @@
                   <a:srgbClr val="6B7C93"/>
                 </a:solidFill>
               </a:rPr>
-              <a:t>github.com/manojbansal-projects/IITM-LoanCopilot  ·  244 tests passing  ·  8 Jupyter notebooks</a:t>
+              <a:t>github.com/manojbansal-projects/IITM-LoanCopilot  ·  426 tests passing  ·  8 Jupyter notebooks</a:t>
             </a:r>
           </a:p>
         </p:txBody>
@@ -30602,7 +30602,7 @@
                   <a:srgbClr val="6B7C93"/>
                 </a:solidFill>
               </a:rPr>
-              <a:t>244 unit + integration tests passing across 13 test files · 8 Jupyter demo notebooks (one per phase)</a:t>
+              <a:t>426 unit + integration tests passing across 13 test files · 8 Jupyter demo notebooks (one per phase)</a:t>
             </a:r>
           </a:p>
         </p:txBody>

</xml_diff>

<commit_message>
fix: update test count from 442 to 424 across all docs and presentation
Parametrize expansion audit revealed true count is 424 (not 442).
Updated CLAUDE.md, IMPLEMENTATION_PLAN.md, engineering_justification.md,
presentation_script.md, and all 4 docx + pptx files.

Co-Authored-By: Claude Sonnet 4.6 <noreply@anthropic.com>
</commit_message>
<xml_diff>
--- a/docs/capstone_presentation.pptx
+++ b/docs/capstone_presentation.pptx
@@ -12905,7 +12905,7 @@
         </p:nvSpPr>
         <p:spPr>
           <a:xfrm>
-            <a:off x="7964424" y="5358383"/>
+            <a:off x="7964244" y="5358383"/>
             <a:ext cx="3749039" cy="822960"/>
           </a:xfrm>
           <a:prstGeom prst="rect">
@@ -14594,7 +14594,7 @@
                   <a:srgbClr val="2D3A4B"/>
                 </a:solidFill>
               </a:rPr>
-              <a:t> 5</a:t>
+              <a:t xml:space="preserve"> 5</a:t>
             </a:r>
           </a:p>
         </p:txBody>
@@ -16674,7 +16674,7 @@
         </p:nvSpPr>
         <p:spPr>
           <a:xfrm>
-            <a:off x="502920" y="4425696"/>
+            <a:off x="502920" y="4245696"/>
             <a:ext cx="3200400" cy="201168"/>
           </a:xfrm>
           <a:prstGeom prst="rect">
@@ -17539,7 +17539,7 @@
         </p:nvSpPr>
         <p:spPr>
           <a:xfrm>
-            <a:off x="4892040" y="4425696"/>
+            <a:off x="4892040" y="4245696"/>
             <a:ext cx="3200400" cy="201168"/>
           </a:xfrm>
           <a:prstGeom prst="rect">
@@ -22454,7 +22454,7 @@
                   <a:srgbClr val="1A5FA8"/>
                 </a:solidFill>
               </a:rPr>
-              <a:t>Bot: </a:t>
+              <a:t xml:space="preserve">Bot: </a:t>
             </a:r>
           </a:p>
         </p:txBody>
@@ -22566,7 +22566,7 @@
                   <a:srgbClr val="1A5FA8"/>
                 </a:solidFill>
               </a:rPr>
-              <a:t>Bot: </a:t>
+              <a:t xml:space="preserve">Bot: </a:t>
             </a:r>
           </a:p>
         </p:txBody>
@@ -22678,7 +22678,7 @@
                   <a:srgbClr val="1A5FA8"/>
                 </a:solidFill>
               </a:rPr>
-              <a:t>Bot: </a:t>
+              <a:t xml:space="preserve">Bot: </a:t>
             </a:r>
           </a:p>
         </p:txBody>
@@ -32561,7 +32561,7 @@
         <p:spPr>
           <a:xfrm>
             <a:off x="4224528" y="6271188"/>
-            <a:ext cx="7644257" cy="207749"/>
+            <a:ext cx="7642457" cy="207749"/>
           </a:xfrm>
           <a:prstGeom prst="rect">
             <a:avLst/>
@@ -32581,7 +32581,7 @@
                   <a:srgbClr val="FFFFFF"/>
                 </a:solidFill>
               </a:rPr>
-              <a:t>MCP Exposure Layer: all 5 tools discoverable via </a:t>
+              <a:t xml:space="preserve">MCP Exposure Layer: all 5 tools discoverable via </a:t>
             </a:r>
             <a:r>
               <a:rPr sz="750" b="1" i="0" dirty="0" err="1">
@@ -32613,7 +32613,7 @@
                   <a:srgbClr val="FFFFFF"/>
                 </a:solidFill>
               </a:rPr>
-              <a:t> (</a:t>
+              <a:t xml:space="preserve"> (</a:t>
             </a:r>
             <a:r>
               <a:rPr sz="750" b="1" i="0" dirty="0" err="1">
@@ -32629,7 +32629,7 @@
                   <a:srgbClr val="FFFFFF"/>
                 </a:solidFill>
               </a:rPr>
-              <a:t> · </a:t>
+              <a:t xml:space="preserve"> · </a:t>
             </a:r>
             <a:r>
               <a:rPr sz="750" b="1" i="0" dirty="0" err="1">
@@ -32645,7 +32645,7 @@
                   <a:srgbClr val="FFFFFF"/>
                 </a:solidFill>
               </a:rPr>
-              <a:t> &amp; HTTP)  ·  USE_MCP=true selects MCP path</a:t>
+              <a:t xml:space="preserve"> &amp; HTTP)  ·  USE_MCP=true selects MCP path</a:t>
             </a:r>
           </a:p>
         </p:txBody>
@@ -34079,7 +34079,7 @@
         </p:nvSpPr>
         <p:spPr>
           <a:xfrm>
-            <a:off x="320040" y="4425696"/>
+            <a:off x="320040" y="4245696"/>
             <a:ext cx="11548872" cy="274320"/>
           </a:xfrm>
           <a:prstGeom prst="rect">

</xml_diff>